<commit_message>
docs(ppt): populate QUANTA presentation template with multi-model tournament results and trajectory charts
</commit_message>
<xml_diff>
--- a/ppt/QUANTA_PPT.pptx
+++ b/ppt/QUANTA_PPT.pptx
@@ -6929,6 +6929,10 @@
             <a:prstDash val="solid"/>
           </a:ln>
         </p:spPr>
+        <p:txBody>
+          <a:bodyPr/>
+          <a:p/>
+        </p:txBody>
       </p:sp>
       <p:sp>
         <p:nvSpPr>
@@ -7100,6 +7104,10 @@
             <a:prstDash val="solid"/>
           </a:ln>
         </p:spPr>
+        <p:txBody>
+          <a:bodyPr/>
+          <a:p/>
+        </p:txBody>
       </p:sp>
       <p:sp>
         <p:nvSpPr>
@@ -7292,6 +7300,10 @@
             <a:prstDash val="solid"/>
           </a:ln>
         </p:spPr>
+        <p:txBody>
+          <a:bodyPr/>
+          <a:p/>
+        </p:txBody>
       </p:sp>
       <p:sp>
         <p:nvSpPr>
@@ -7500,6 +7512,10 @@
             <a:prstDash val="dash"/>
           </a:ln>
         </p:spPr>
+        <p:txBody>
+          <a:bodyPr/>
+          <a:p/>
+        </p:txBody>
       </p:sp>
       <p:sp>
         <p:nvSpPr>
@@ -7521,40 +7537,7 @@
         <p:txBody>
           <a:bodyPr wrap="square" lIns="127000" tIns="127000" rIns="127000" bIns="127000" rtlCol="0" anchor="ctr"/>
           <a:lstStyle/>
-          <a:p>
-            <a:pPr marL="0" indent="0" algn="ctr">
-              <a:buNone/>
-            </a:pPr>
-            <a:r>
-              <a:rPr lang="en-US" sz="1400" dirty="0">
-                <a:solidFill>
-                  <a:srgbClr val="1D4ED8"/>
-                </a:solidFill>
-                <a:latin typeface="Courier New" pitchFamily="34" charset="0"/>
-                <a:ea typeface="Courier New" pitchFamily="34" charset="-122"/>
-                <a:cs typeface="Courier New" pitchFamily="34" charset="-120"/>
-              </a:rPr>
-              <a:t>INSERT YOUR RUN LOG TABLE HERE</a:t>
-            </a:r>
-            <a:endParaRPr lang="en-US" sz="1400" dirty="0"/>
-          </a:p>
-          <a:p>
-            <a:pPr marL="0" indent="0" algn="ctr">
-              <a:buNone/>
-            </a:pPr>
-            <a:r>
-              <a:rPr lang="en-US" sz="1400" dirty="0">
-                <a:solidFill>
-                  <a:srgbClr val="1D4ED8"/>
-                </a:solidFill>
-                <a:latin typeface="Courier New" pitchFamily="34" charset="0"/>
-                <a:ea typeface="Courier New" pitchFamily="34" charset="-122"/>
-                <a:cs typeface="Courier New" pitchFamily="34" charset="-120"/>
-              </a:rPr>
-              <a:t>run | model | params | val ROC-AUC | overfit gap</a:t>
-            </a:r>
-            <a:endParaRPr lang="en-US" sz="1400" dirty="0"/>
-          </a:p>
+          <a:p/>
         </p:txBody>
       </p:sp>
       <p:sp>
@@ -7605,6 +7588,854 @@
           </a:p>
         </p:txBody>
       </p:sp>
+      <p:graphicFrame>
+        <p:nvGraphicFramePr>
+          <p:cNvPr id="26" name="Table 25"/>
+          <p:cNvGraphicFramePr>
+            <a:graphicFrameLocks noGrp="1"/>
+          </p:cNvGraphicFramePr>
+          <p:nvPr/>
+        </p:nvGraphicFramePr>
+        <p:xfrm>
+          <a:off x="548640" y="4370832"/>
+          <a:ext cx="11109960" cy="1691640"/>
+        </p:xfrm>
+        <a:graphic>
+          <a:graphicData uri="http://schemas.openxmlformats.org/drawingml/2006/table">
+            <a:tbl>
+              <a:tblPr firstRow="1" bandRow="1">
+                <a:tableStyleId>{5C22544A-7EE6-4342-B048-85BDC9FD1C3A}</a:tableStyleId>
+              </a:tblPr>
+              <a:tblGrid>
+                <a:gridCol w="1005840"/>
+                <a:gridCol w="2468880"/>
+                <a:gridCol w="4343400"/>
+                <a:gridCol w="1645920"/>
+                <a:gridCol w="1645920"/>
+              </a:tblGrid>
+              <a:tr h="241662">
+                <a:tc>
+                  <a:txBody>
+                    <a:bodyPr/>
+                    <a:lstStyle/>
+                    <a:p>
+                      <a:pPr algn="ctr">
+                        <a:defRPr sz="900" b="1">
+                          <a:solidFill>
+                            <a:srgbClr val="0F766E"/>
+                          </a:solidFill>
+                        </a:defRPr>
+                      </a:pPr>
+                      <a:r>
+                        <a:t>Run</a:t>
+                      </a:r>
+                    </a:p>
+                  </a:txBody>
+                  <a:tcPr>
+                    <a:solidFill>
+                      <a:srgbClr val="F1F5F9"/>
+                    </a:solidFill>
+                  </a:tcPr>
+                </a:tc>
+                <a:tc>
+                  <a:txBody>
+                    <a:bodyPr/>
+                    <a:lstStyle/>
+                    <a:p>
+                      <a:pPr algn="l">
+                        <a:defRPr sz="900" b="1">
+                          <a:solidFill>
+                            <a:srgbClr val="0F766E"/>
+                          </a:solidFill>
+                        </a:defRPr>
+                      </a:pPr>
+                      <a:r>
+                        <a:t>Model Family</a:t>
+                      </a:r>
+                    </a:p>
+                  </a:txBody>
+                  <a:tcPr>
+                    <a:solidFill>
+                      <a:srgbClr val="F1F5F9"/>
+                    </a:solidFill>
+                  </a:tcPr>
+                </a:tc>
+                <a:tc>
+                  <a:txBody>
+                    <a:bodyPr/>
+                    <a:lstStyle/>
+                    <a:p>
+                      <a:pPr algn="l">
+                        <a:defRPr sz="900" b="1">
+                          <a:solidFill>
+                            <a:srgbClr val="0F766E"/>
+                          </a:solidFill>
+                        </a:defRPr>
+                      </a:pPr>
+                      <a:r>
+                        <a:t>Key Parameters &amp; Regularization</a:t>
+                      </a:r>
+                    </a:p>
+                  </a:txBody>
+                  <a:tcPr>
+                    <a:solidFill>
+                      <a:srgbClr val="F1F5F9"/>
+                    </a:solidFill>
+                  </a:tcPr>
+                </a:tc>
+                <a:tc>
+                  <a:txBody>
+                    <a:bodyPr/>
+                    <a:lstStyle/>
+                    <a:p>
+                      <a:pPr algn="ctr">
+                        <a:defRPr sz="900" b="1">
+                          <a:solidFill>
+                            <a:srgbClr val="0F766E"/>
+                          </a:solidFill>
+                        </a:defRPr>
+                      </a:pPr>
+                      <a:r>
+                        <a:t>Val ROC-AUC</a:t>
+                      </a:r>
+                    </a:p>
+                  </a:txBody>
+                  <a:tcPr>
+                    <a:solidFill>
+                      <a:srgbClr val="F1F5F9"/>
+                    </a:solidFill>
+                  </a:tcPr>
+                </a:tc>
+                <a:tc>
+                  <a:txBody>
+                    <a:bodyPr/>
+                    <a:lstStyle/>
+                    <a:p>
+                      <a:pPr algn="ctr">
+                        <a:defRPr sz="900" b="1">
+                          <a:solidFill>
+                            <a:srgbClr val="0F766E"/>
+                          </a:solidFill>
+                        </a:defRPr>
+                      </a:pPr>
+                      <a:r>
+                        <a:t>Overfit Gap (Ω)</a:t>
+                      </a:r>
+                    </a:p>
+                  </a:txBody>
+                  <a:tcPr>
+                    <a:solidFill>
+                      <a:srgbClr val="F1F5F9"/>
+                    </a:solidFill>
+                  </a:tcPr>
+                </a:tc>
+              </a:tr>
+              <a:tr h="241662">
+                <a:tc>
+                  <a:txBody>
+                    <a:bodyPr/>
+                    <a:lstStyle/>
+                    <a:p>
+                      <a:pPr algn="ctr">
+                        <a:defRPr sz="850" b="0">
+                          <a:solidFill>
+                            <a:srgbClr val="0B1F3A"/>
+                          </a:solidFill>
+                        </a:defRPr>
+                      </a:pPr>
+                      <a:r>
+                        <a:t>Run 01</a:t>
+                      </a:r>
+                    </a:p>
+                  </a:txBody>
+                  <a:tcPr>
+                    <a:solidFill>
+                      <a:srgbClr val="FFFFFF"/>
+                    </a:solidFill>
+                  </a:tcPr>
+                </a:tc>
+                <a:tc>
+                  <a:txBody>
+                    <a:bodyPr/>
+                    <a:lstStyle/>
+                    <a:p>
+                      <a:pPr algn="l">
+                        <a:defRPr sz="850" b="0">
+                          <a:solidFill>
+                            <a:srgbClr val="0B1F3A"/>
+                          </a:solidFill>
+                        </a:defRPr>
+                      </a:pPr>
+                      <a:r>
+                        <a:t>CatBoost (Baseline)</a:t>
+                      </a:r>
+                    </a:p>
+                  </a:txBody>
+                  <a:tcPr>
+                    <a:solidFill>
+                      <a:srgbClr val="FFFFFF"/>
+                    </a:solidFill>
+                  </a:tcPr>
+                </a:tc>
+                <a:tc>
+                  <a:txBody>
+                    <a:bodyPr/>
+                    <a:lstStyle/>
+                    <a:p>
+                      <a:pPr algn="l">
+                        <a:defRPr sz="850" b="0">
+                          <a:solidFill>
+                            <a:srgbClr val="0B1F3A"/>
+                          </a:solidFill>
+                        </a:defRPr>
+                      </a:pPr>
+                      <a:r>
+                        <a:t>Depth 7, L2 3.42, LR 0.046, Trees 1000</a:t>
+                      </a:r>
+                    </a:p>
+                  </a:txBody>
+                  <a:tcPr>
+                    <a:solidFill>
+                      <a:srgbClr val="FFFFFF"/>
+                    </a:solidFill>
+                  </a:tcPr>
+                </a:tc>
+                <a:tc>
+                  <a:txBody>
+                    <a:bodyPr/>
+                    <a:lstStyle/>
+                    <a:p>
+                      <a:pPr algn="ctr">
+                        <a:defRPr sz="850" b="0">
+                          <a:solidFill>
+                            <a:srgbClr val="0B1F3A"/>
+                          </a:solidFill>
+                        </a:defRPr>
+                      </a:pPr>
+                      <a:r>
+                        <a:t>0.84974</a:t>
+                      </a:r>
+                    </a:p>
+                  </a:txBody>
+                  <a:tcPr>
+                    <a:solidFill>
+                      <a:srgbClr val="FFFFFF"/>
+                    </a:solidFill>
+                  </a:tcPr>
+                </a:tc>
+                <a:tc>
+                  <a:txBody>
+                    <a:bodyPr/>
+                    <a:lstStyle/>
+                    <a:p>
+                      <a:pPr algn="ctr">
+                        <a:defRPr sz="850" b="0">
+                          <a:solidFill>
+                            <a:srgbClr val="0B1F3A"/>
+                          </a:solidFill>
+                        </a:defRPr>
+                      </a:pPr>
+                      <a:r>
+                        <a:t>11.27%</a:t>
+                      </a:r>
+                    </a:p>
+                  </a:txBody>
+                  <a:tcPr>
+                    <a:solidFill>
+                      <a:srgbClr val="FFFFFF"/>
+                    </a:solidFill>
+                  </a:tcPr>
+                </a:tc>
+              </a:tr>
+              <a:tr h="241662">
+                <a:tc>
+                  <a:txBody>
+                    <a:bodyPr/>
+                    <a:lstStyle/>
+                    <a:p>
+                      <a:pPr algn="ctr">
+                        <a:defRPr sz="850" b="0">
+                          <a:solidFill>
+                            <a:srgbClr val="0B1F3A"/>
+                          </a:solidFill>
+                        </a:defRPr>
+                      </a:pPr>
+                      <a:r>
+                        <a:t>Run 02</a:t>
+                      </a:r>
+                    </a:p>
+                  </a:txBody>
+                  <a:tcPr>
+                    <a:solidFill>
+                      <a:srgbClr val="FFFFFF"/>
+                    </a:solidFill>
+                  </a:tcPr>
+                </a:tc>
+                <a:tc>
+                  <a:txBody>
+                    <a:bodyPr/>
+                    <a:lstStyle/>
+                    <a:p>
+                      <a:pPr algn="l">
+                        <a:defRPr sz="850" b="0">
+                          <a:solidFill>
+                            <a:srgbClr val="0B1F3A"/>
+                          </a:solidFill>
+                        </a:defRPr>
+                      </a:pPr>
+                      <a:r>
+                        <a:t>LightGBM</a:t>
+                      </a:r>
+                    </a:p>
+                  </a:txBody>
+                  <a:tcPr>
+                    <a:solidFill>
+                      <a:srgbClr val="FFFFFF"/>
+                    </a:solidFill>
+                  </a:tcPr>
+                </a:tc>
+                <a:tc>
+                  <a:txBody>
+                    <a:bodyPr/>
+                    <a:lstStyle/>
+                    <a:p>
+                      <a:pPr algn="l">
+                        <a:defRPr sz="850" b="0">
+                          <a:solidFill>
+                            <a:srgbClr val="0B1F3A"/>
+                          </a:solidFill>
+                        </a:defRPr>
+                      </a:pPr>
+                      <a:r>
+                        <a:t>Depth 5, L2 2.20, LR 0.043, Histogram</a:t>
+                      </a:r>
+                    </a:p>
+                  </a:txBody>
+                  <a:tcPr>
+                    <a:solidFill>
+                      <a:srgbClr val="FFFFFF"/>
+                    </a:solidFill>
+                  </a:tcPr>
+                </a:tc>
+                <a:tc>
+                  <a:txBody>
+                    <a:bodyPr/>
+                    <a:lstStyle/>
+                    <a:p>
+                      <a:pPr algn="ctr">
+                        <a:defRPr sz="850" b="0">
+                          <a:solidFill>
+                            <a:srgbClr val="0B1F3A"/>
+                          </a:solidFill>
+                        </a:defRPr>
+                      </a:pPr>
+                      <a:r>
+                        <a:t>0.84845</a:t>
+                      </a:r>
+                    </a:p>
+                  </a:txBody>
+                  <a:tcPr>
+                    <a:solidFill>
+                      <a:srgbClr val="FFFFFF"/>
+                    </a:solidFill>
+                  </a:tcPr>
+                </a:tc>
+                <a:tc>
+                  <a:txBody>
+                    <a:bodyPr/>
+                    <a:lstStyle/>
+                    <a:p>
+                      <a:pPr algn="ctr">
+                        <a:defRPr sz="850" b="0">
+                          <a:solidFill>
+                            <a:srgbClr val="0B1F3A"/>
+                          </a:solidFill>
+                        </a:defRPr>
+                      </a:pPr>
+                      <a:r>
+                        <a:t>18.98%</a:t>
+                      </a:r>
+                    </a:p>
+                  </a:txBody>
+                  <a:tcPr>
+                    <a:solidFill>
+                      <a:srgbClr val="FFFFFF"/>
+                    </a:solidFill>
+                  </a:tcPr>
+                </a:tc>
+              </a:tr>
+              <a:tr h="241662">
+                <a:tc>
+                  <a:txBody>
+                    <a:bodyPr/>
+                    <a:lstStyle/>
+                    <a:p>
+                      <a:pPr algn="ctr">
+                        <a:defRPr sz="850" b="0">
+                          <a:solidFill>
+                            <a:srgbClr val="0B1F3A"/>
+                          </a:solidFill>
+                        </a:defRPr>
+                      </a:pPr>
+                      <a:r>
+                        <a:t>Run 03</a:t>
+                      </a:r>
+                    </a:p>
+                  </a:txBody>
+                  <a:tcPr>
+                    <a:solidFill>
+                      <a:srgbClr val="FFFFFF"/>
+                    </a:solidFill>
+                  </a:tcPr>
+                </a:tc>
+                <a:tc>
+                  <a:txBody>
+                    <a:bodyPr/>
+                    <a:lstStyle/>
+                    <a:p>
+                      <a:pPr algn="l">
+                        <a:defRPr sz="850" b="0">
+                          <a:solidFill>
+                            <a:srgbClr val="0B1F3A"/>
+                          </a:solidFill>
+                        </a:defRPr>
+                      </a:pPr>
+                      <a:r>
+                        <a:t>XGBoost</a:t>
+                      </a:r>
+                    </a:p>
+                  </a:txBody>
+                  <a:tcPr>
+                    <a:solidFill>
+                      <a:srgbClr val="FFFFFF"/>
+                    </a:solidFill>
+                  </a:tcPr>
+                </a:tc>
+                <a:tc>
+                  <a:txBody>
+                    <a:bodyPr/>
+                    <a:lstStyle/>
+                    <a:p>
+                      <a:pPr algn="l">
+                        <a:defRPr sz="850" b="0">
+                          <a:solidFill>
+                            <a:srgbClr val="0B1F3A"/>
+                          </a:solidFill>
+                        </a:defRPr>
+                      </a:pPr>
+                      <a:r>
+                        <a:t>Depth 5, L2 3.85, LR 0.053, Subsample 0.93</a:t>
+                      </a:r>
+                    </a:p>
+                  </a:txBody>
+                  <a:tcPr>
+                    <a:solidFill>
+                      <a:srgbClr val="FFFFFF"/>
+                    </a:solidFill>
+                  </a:tcPr>
+                </a:tc>
+                <a:tc>
+                  <a:txBody>
+                    <a:bodyPr/>
+                    <a:lstStyle/>
+                    <a:p>
+                      <a:pPr algn="ctr">
+                        <a:defRPr sz="850" b="0">
+                          <a:solidFill>
+                            <a:srgbClr val="0B1F3A"/>
+                          </a:solidFill>
+                        </a:defRPr>
+                      </a:pPr>
+                      <a:r>
+                        <a:t>0.84879</a:t>
+                      </a:r>
+                    </a:p>
+                  </a:txBody>
+                  <a:tcPr>
+                    <a:solidFill>
+                      <a:srgbClr val="FFFFFF"/>
+                    </a:solidFill>
+                  </a:tcPr>
+                </a:tc>
+                <a:tc>
+                  <a:txBody>
+                    <a:bodyPr/>
+                    <a:lstStyle/>
+                    <a:p>
+                      <a:pPr algn="ctr">
+                        <a:defRPr sz="850" b="0">
+                          <a:solidFill>
+                            <a:srgbClr val="0B1F3A"/>
+                          </a:solidFill>
+                        </a:defRPr>
+                      </a:pPr>
+                      <a:r>
+                        <a:t>19.92%</a:t>
+                      </a:r>
+                    </a:p>
+                  </a:txBody>
+                  <a:tcPr>
+                    <a:solidFill>
+                      <a:srgbClr val="FFFFFF"/>
+                    </a:solidFill>
+                  </a:tcPr>
+                </a:tc>
+              </a:tr>
+              <a:tr h="241662">
+                <a:tc>
+                  <a:txBody>
+                    <a:bodyPr/>
+                    <a:lstStyle/>
+                    <a:p>
+                      <a:pPr algn="ctr">
+                        <a:defRPr sz="850" b="0">
+                          <a:solidFill>
+                            <a:srgbClr val="0B1F3A"/>
+                          </a:solidFill>
+                        </a:defRPr>
+                      </a:pPr>
+                      <a:r>
+                        <a:t>Run 05</a:t>
+                      </a:r>
+                    </a:p>
+                  </a:txBody>
+                  <a:tcPr>
+                    <a:solidFill>
+                      <a:srgbClr val="FFFFFF"/>
+                    </a:solidFill>
+                  </a:tcPr>
+                </a:tc>
+                <a:tc>
+                  <a:txBody>
+                    <a:bodyPr/>
+                    <a:lstStyle/>
+                    <a:p>
+                      <a:pPr algn="l">
+                        <a:defRPr sz="850" b="0">
+                          <a:solidFill>
+                            <a:srgbClr val="0B1F3A"/>
+                          </a:solidFill>
+                        </a:defRPr>
+                      </a:pPr>
+                      <a:r>
+                        <a:t>Logistic Regression</a:t>
+                      </a:r>
+                    </a:p>
+                  </a:txBody>
+                  <a:tcPr>
+                    <a:solidFill>
+                      <a:srgbClr val="FFFFFF"/>
+                    </a:solidFill>
+                  </a:tcPr>
+                </a:tc>
+                <a:tc>
+                  <a:txBody>
+                    <a:bodyPr/>
+                    <a:lstStyle/>
+                    <a:p>
+                      <a:pPr algn="l">
+                        <a:defRPr sz="850" b="0">
+                          <a:solidFill>
+                            <a:srgbClr val="0B1F3A"/>
+                          </a:solidFill>
+                        </a:defRPr>
+                      </a:pPr>
+                      <a:r>
+                        <a:t>L-BFGS, L2 Penalty, C=1.0, Standardized</a:t>
+                      </a:r>
+                    </a:p>
+                  </a:txBody>
+                  <a:tcPr>
+                    <a:solidFill>
+                      <a:srgbClr val="FFFFFF"/>
+                    </a:solidFill>
+                  </a:tcPr>
+                </a:tc>
+                <a:tc>
+                  <a:txBody>
+                    <a:bodyPr/>
+                    <a:lstStyle/>
+                    <a:p>
+                      <a:pPr algn="ctr">
+                        <a:defRPr sz="850" b="0">
+                          <a:solidFill>
+                            <a:srgbClr val="0B1F3A"/>
+                          </a:solidFill>
+                        </a:defRPr>
+                      </a:pPr>
+                      <a:r>
+                        <a:t>0.84681</a:t>
+                      </a:r>
+                    </a:p>
+                  </a:txBody>
+                  <a:tcPr>
+                    <a:solidFill>
+                      <a:srgbClr val="FFFFFF"/>
+                    </a:solidFill>
+                  </a:tcPr>
+                </a:tc>
+                <a:tc>
+                  <a:txBody>
+                    <a:bodyPr/>
+                    <a:lstStyle/>
+                    <a:p>
+                      <a:pPr algn="ctr">
+                        <a:defRPr sz="850" b="0">
+                          <a:solidFill>
+                            <a:srgbClr val="0B1F3A"/>
+                          </a:solidFill>
+                        </a:defRPr>
+                      </a:pPr>
+                      <a:r>
+                        <a:t>8.33%</a:t>
+                      </a:r>
+                    </a:p>
+                  </a:txBody>
+                  <a:tcPr>
+                    <a:solidFill>
+                      <a:srgbClr val="FFFFFF"/>
+                    </a:solidFill>
+                  </a:tcPr>
+                </a:tc>
+              </a:tr>
+              <a:tr h="241662">
+                <a:tc>
+                  <a:txBody>
+                    <a:bodyPr/>
+                    <a:lstStyle/>
+                    <a:p>
+                      <a:pPr algn="ctr">
+                        <a:defRPr sz="850" b="0">
+                          <a:solidFill>
+                            <a:srgbClr val="0B1F3A"/>
+                          </a:solidFill>
+                        </a:defRPr>
+                      </a:pPr>
+                      <a:r>
+                        <a:t>Run 08</a:t>
+                      </a:r>
+                    </a:p>
+                  </a:txBody>
+                  <a:tcPr>
+                    <a:solidFill>
+                      <a:srgbClr val="FFFFFF"/>
+                    </a:solidFill>
+                  </a:tcPr>
+                </a:tc>
+                <a:tc>
+                  <a:txBody>
+                    <a:bodyPr/>
+                    <a:lstStyle/>
+                    <a:p>
+                      <a:pPr algn="l">
+                        <a:defRPr sz="850" b="0">
+                          <a:solidFill>
+                            <a:srgbClr val="0B1F3A"/>
+                          </a:solidFill>
+                        </a:defRPr>
+                      </a:pPr>
+                      <a:r>
+                        <a:t>CatBoost (Tuned)</a:t>
+                      </a:r>
+                    </a:p>
+                  </a:txBody>
+                  <a:tcPr>
+                    <a:solidFill>
+                      <a:srgbClr val="FFFFFF"/>
+                    </a:solidFill>
+                  </a:tcPr>
+                </a:tc>
+                <a:tc>
+                  <a:txBody>
+                    <a:bodyPr/>
+                    <a:lstStyle/>
+                    <a:p>
+                      <a:pPr algn="l">
+                        <a:defRPr sz="850" b="0">
+                          <a:solidFill>
+                            <a:srgbClr val="0B1F3A"/>
+                          </a:solidFill>
+                        </a:defRPr>
+                      </a:pPr>
+                      <a:r>
+                        <a:t>Depth 5, L2 5.04, LR 0.033, Subsample 0.8</a:t>
+                      </a:r>
+                    </a:p>
+                  </a:txBody>
+                  <a:tcPr>
+                    <a:solidFill>
+                      <a:srgbClr val="FFFFFF"/>
+                    </a:solidFill>
+                  </a:tcPr>
+                </a:tc>
+                <a:tc>
+                  <a:txBody>
+                    <a:bodyPr/>
+                    <a:lstStyle/>
+                    <a:p>
+                      <a:pPr algn="ctr">
+                        <a:defRPr sz="850" b="0">
+                          <a:solidFill>
+                            <a:srgbClr val="0B1F3A"/>
+                          </a:solidFill>
+                        </a:defRPr>
+                      </a:pPr>
+                      <a:r>
+                        <a:t>0.85027</a:t>
+                      </a:r>
+                    </a:p>
+                  </a:txBody>
+                  <a:tcPr>
+                    <a:solidFill>
+                      <a:srgbClr val="FFFFFF"/>
+                    </a:solidFill>
+                  </a:tcPr>
+                </a:tc>
+                <a:tc>
+                  <a:txBody>
+                    <a:bodyPr/>
+                    <a:lstStyle/>
+                    <a:p>
+                      <a:pPr algn="ctr">
+                        <a:defRPr sz="850" b="0">
+                          <a:solidFill>
+                            <a:srgbClr val="0B1F3A"/>
+                          </a:solidFill>
+                        </a:defRPr>
+                      </a:pPr>
+                      <a:r>
+                        <a:t>7.46%</a:t>
+                      </a:r>
+                    </a:p>
+                  </a:txBody>
+                  <a:tcPr>
+                    <a:solidFill>
+                      <a:srgbClr val="FFFFFF"/>
+                    </a:solidFill>
+                  </a:tcPr>
+                </a:tc>
+              </a:tr>
+              <a:tr h="241668">
+                <a:tc>
+                  <a:txBody>
+                    <a:bodyPr/>
+                    <a:lstStyle/>
+                    <a:p>
+                      <a:pPr algn="ctr">
+                        <a:defRPr sz="850" b="1">
+                          <a:solidFill>
+                            <a:srgbClr val="DC2626"/>
+                          </a:solidFill>
+                        </a:defRPr>
+                      </a:pPr>
+                      <a:r>
+                        <a:t>Run 12</a:t>
+                      </a:r>
+                    </a:p>
+                  </a:txBody>
+                  <a:tcPr>
+                    <a:solidFill>
+                      <a:srgbClr val="FEF2F2"/>
+                    </a:solidFill>
+                  </a:tcPr>
+                </a:tc>
+                <a:tc>
+                  <a:txBody>
+                    <a:bodyPr/>
+                    <a:lstStyle/>
+                    <a:p>
+                      <a:pPr algn="l">
+                        <a:defRPr sz="850" b="1">
+                          <a:solidFill>
+                            <a:srgbClr val="DC2626"/>
+                          </a:solidFill>
+                        </a:defRPr>
+                      </a:pPr>
+                      <a:r>
+                        <a:t>CatBoost (Champion ★)</a:t>
+                      </a:r>
+                    </a:p>
+                  </a:txBody>
+                  <a:tcPr>
+                    <a:solidFill>
+                      <a:srgbClr val="FEF2F2"/>
+                    </a:solidFill>
+                  </a:tcPr>
+                </a:tc>
+                <a:tc>
+                  <a:txBody>
+                    <a:bodyPr/>
+                    <a:lstStyle/>
+                    <a:p>
+                      <a:pPr algn="l">
+                        <a:defRPr sz="850" b="1">
+                          <a:solidFill>
+                            <a:srgbClr val="DC2626"/>
+                          </a:solidFill>
+                        </a:defRPr>
+                      </a:pPr>
+                      <a:r>
+                        <a:t>Depth 5, L2 11.72, LR 0.020, Balanced</a:t>
+                      </a:r>
+                    </a:p>
+                  </a:txBody>
+                  <a:tcPr>
+                    <a:solidFill>
+                      <a:srgbClr val="FEF2F2"/>
+                    </a:solidFill>
+                  </a:tcPr>
+                </a:tc>
+                <a:tc>
+                  <a:txBody>
+                    <a:bodyPr/>
+                    <a:lstStyle/>
+                    <a:p>
+                      <a:pPr algn="ctr">
+                        <a:defRPr sz="850" b="1">
+                          <a:solidFill>
+                            <a:srgbClr val="DC2626"/>
+                          </a:solidFill>
+                        </a:defRPr>
+                      </a:pPr>
+                      <a:r>
+                        <a:t>0.85058</a:t>
+                      </a:r>
+                    </a:p>
+                  </a:txBody>
+                  <a:tcPr>
+                    <a:solidFill>
+                      <a:srgbClr val="FEF2F2"/>
+                    </a:solidFill>
+                  </a:tcPr>
+                </a:tc>
+                <a:tc>
+                  <a:txBody>
+                    <a:bodyPr/>
+                    <a:lstStyle/>
+                    <a:p>
+                      <a:pPr algn="ctr">
+                        <a:defRPr sz="850" b="1">
+                          <a:solidFill>
+                            <a:srgbClr val="DC2626"/>
+                          </a:solidFill>
+                        </a:defRPr>
+                      </a:pPr>
+                      <a:r>
+                        <a:t>6.88% (Holdout: 0.8443)</a:t>
+                      </a:r>
+                    </a:p>
+                  </a:txBody>
+                  <a:tcPr>
+                    <a:solidFill>
+                      <a:srgbClr val="FEF2F2"/>
+                    </a:solidFill>
+                  </a:tcPr>
+                </a:tc>
+              </a:tr>
+            </a:tbl>
+          </a:graphicData>
+        </a:graphic>
+      </p:graphicFrame>
     </p:spTree>
   </p:cSld>
   <p:clrMapOvr>
@@ -9224,6 +10055,11 @@
                     <a:p>
                       <a:pPr marL="0" indent="0" algn="l">
                         <a:buNone/>
+                        <a:defRPr sz="1100">
+                          <a:solidFill>
+                            <a:srgbClr val="0B1F3A"/>
+                          </a:solidFill>
+                        </a:defRPr>
                       </a:pPr>
                       <a:r>
                         <a:rPr lang="en-US" sz="1300" b="1" dirty="0">
@@ -9290,25 +10126,75 @@
                     <a:bodyPr/>
                     <a:lstStyle/>
                     <a:p>
-                      <a:pPr marL="0" indent="0" algn="ctr">
-                        <a:buNone/>
-                      </a:pPr>
-                      <a:r>
-                        <a:rPr lang="en-US" sz="1400" dirty="0">
+                      <a:pPr>
+                        <a:defRPr sz="1100">
                           <a:solidFill>
                             <a:srgbClr val="0B1F3A"/>
                           </a:solidFill>
-                          <a:latin typeface="Calibri" pitchFamily="34" charset="0"/>
-                          <a:ea typeface="Calibri" pitchFamily="34" charset="-122"/>
-                          <a:cs typeface="Calibri" pitchFamily="34" charset="-120"/>
-                        </a:rPr>
-                        <a:t>[  ]</a:t>
+                        </a:defRPr>
+                      </a:pPr>
+                      <a:r>
+                        <a:t>0.8468</a:t>
                       </a:r>
-                      <a:endParaRPr lang="en-US" sz="1400" dirty="0">
-                        <a:latin typeface="Calibri" charset="0"/>
-                        <a:ea typeface="Calibri" charset="0"/>
-                        <a:cs typeface="Calibri" charset="0"/>
-                      </a:endParaRPr>
+                    </a:p>
+                  </a:txBody>
+                  <a:tcPr anchor="ctr">
+                    <a:lnL w="12700" cap="flat" cmpd="sng" algn="ctr">
+                      <a:solidFill>
+                        <a:srgbClr val="CFCBBD"/>
+                      </a:solidFill>
+                      <a:prstDash val="solid"/>
+                      <a:round/>
+                      <a:headEnd type="none" w="med" len="med"/>
+                      <a:tailEnd type="none" w="med" len="med"/>
+                    </a:lnL>
+                    <a:lnR w="12700" cap="flat" cmpd="sng" algn="ctr">
+                      <a:solidFill>
+                        <a:srgbClr val="CFCBBD"/>
+                      </a:solidFill>
+                      <a:prstDash val="solid"/>
+                      <a:round/>
+                      <a:headEnd type="none" w="med" len="med"/>
+                      <a:tailEnd type="none" w="med" len="med"/>
+                    </a:lnR>
+                    <a:lnT w="12700" cap="flat" cmpd="sng" algn="ctr">
+                      <a:solidFill>
+                        <a:srgbClr val="CFCBBD"/>
+                      </a:solidFill>
+                      <a:prstDash val="solid"/>
+                      <a:round/>
+                      <a:headEnd type="none" w="med" len="med"/>
+                      <a:tailEnd type="none" w="med" len="med"/>
+                    </a:lnT>
+                    <a:lnB w="12700" cap="flat" cmpd="sng" algn="ctr">
+                      <a:solidFill>
+                        <a:srgbClr val="CFCBBD"/>
+                      </a:solidFill>
+                      <a:prstDash val="solid"/>
+                      <a:round/>
+                      <a:headEnd type="none" w="med" len="med"/>
+                      <a:tailEnd type="none" w="med" len="med"/>
+                    </a:lnB>
+                    <a:solidFill>
+                      <a:srgbClr val="FFFFFF"/>
+                    </a:solidFill>
+                  </a:tcPr>
+                </a:tc>
+                <a:tc>
+                  <a:txBody>
+                    <a:bodyPr/>
+                    <a:lstStyle/>
+                    <a:p>
+                      <a:pPr>
+                        <a:defRPr sz="1100">
+                          <a:solidFill>
+                            <a:srgbClr val="0B1F3A"/>
+                          </a:solidFill>
+                        </a:defRPr>
+                      </a:pPr>
+                      <a:r>
+                        <a:t>0.6603</a:t>
+                      </a:r>
                     </a:p>
                   </a:txBody>
                   <a:tcPr anchor="ctr">
@@ -9360,74 +10246,11 @@
                     <a:p>
                       <a:pPr marL="0" indent="0" algn="ctr">
                         <a:buNone/>
-                      </a:pPr>
-                      <a:r>
-                        <a:rPr lang="en-US" sz="1400" dirty="0">
+                        <a:defRPr sz="1100">
                           <a:solidFill>
                             <a:srgbClr val="0B1F3A"/>
                           </a:solidFill>
-                          <a:latin typeface="Calibri" pitchFamily="34" charset="0"/>
-                          <a:ea typeface="Calibri" pitchFamily="34" charset="-122"/>
-                          <a:cs typeface="Calibri" pitchFamily="34" charset="-120"/>
-                        </a:rPr>
-                        <a:t>[  ]</a:t>
-                      </a:r>
-                      <a:endParaRPr lang="en-US" sz="1400" dirty="0">
-                        <a:latin typeface="Calibri" charset="0"/>
-                        <a:ea typeface="Calibri" charset="0"/>
-                        <a:cs typeface="Calibri" charset="0"/>
-                      </a:endParaRPr>
-                    </a:p>
-                  </a:txBody>
-                  <a:tcPr anchor="ctr">
-                    <a:lnL w="12700" cap="flat" cmpd="sng" algn="ctr">
-                      <a:solidFill>
-                        <a:srgbClr val="CFCBBD"/>
-                      </a:solidFill>
-                      <a:prstDash val="solid"/>
-                      <a:round/>
-                      <a:headEnd type="none" w="med" len="med"/>
-                      <a:tailEnd type="none" w="med" len="med"/>
-                    </a:lnL>
-                    <a:lnR w="12700" cap="flat" cmpd="sng" algn="ctr">
-                      <a:solidFill>
-                        <a:srgbClr val="CFCBBD"/>
-                      </a:solidFill>
-                      <a:prstDash val="solid"/>
-                      <a:round/>
-                      <a:headEnd type="none" w="med" len="med"/>
-                      <a:tailEnd type="none" w="med" len="med"/>
-                    </a:lnR>
-                    <a:lnT w="12700" cap="flat" cmpd="sng" algn="ctr">
-                      <a:solidFill>
-                        <a:srgbClr val="CFCBBD"/>
-                      </a:solidFill>
-                      <a:prstDash val="solid"/>
-                      <a:round/>
-                      <a:headEnd type="none" w="med" len="med"/>
-                      <a:tailEnd type="none" w="med" len="med"/>
-                    </a:lnT>
-                    <a:lnB w="12700" cap="flat" cmpd="sng" algn="ctr">
-                      <a:solidFill>
-                        <a:srgbClr val="CFCBBD"/>
-                      </a:solidFill>
-                      <a:prstDash val="solid"/>
-                      <a:round/>
-                      <a:headEnd type="none" w="med" len="med"/>
-                      <a:tailEnd type="none" w="med" len="med"/>
-                    </a:lnB>
-                    <a:solidFill>
-                      <a:srgbClr val="FFFFFF"/>
-                    </a:solidFill>
-                  </a:tcPr>
-                </a:tc>
-                <a:tc>
-                  <a:txBody>
-                    <a:bodyPr/>
-                    <a:lstStyle/>
-                    <a:p>
-                      <a:pPr marL="0" indent="0" algn="ctr">
-                        <a:buNone/>
+                        </a:defRPr>
                       </a:pPr>
                       <a:r>
                         <a:rPr lang="en-US" sz="1400" dirty="0">
@@ -9503,6 +10326,11 @@
                     <a:p>
                       <a:pPr marL="0" indent="0" algn="l">
                         <a:buNone/>
+                        <a:defRPr sz="1100">
+                          <a:solidFill>
+                            <a:srgbClr val="0B1F3A"/>
+                          </a:solidFill>
+                        </a:defRPr>
                       </a:pPr>
                       <a:r>
                         <a:rPr lang="en-US" sz="1300" b="1" dirty="0">
@@ -9569,25 +10397,75 @@
                     <a:bodyPr/>
                     <a:lstStyle/>
                     <a:p>
-                      <a:pPr marL="0" indent="0" algn="ctr">
-                        <a:buNone/>
-                      </a:pPr>
-                      <a:r>
-                        <a:rPr lang="en-US" sz="1400" dirty="0">
+                      <a:pPr>
+                        <a:defRPr sz="1100">
                           <a:solidFill>
                             <a:srgbClr val="0B1F3A"/>
                           </a:solidFill>
-                          <a:latin typeface="Calibri" pitchFamily="34" charset="0"/>
-                          <a:ea typeface="Calibri" pitchFamily="34" charset="-122"/>
-                          <a:cs typeface="Calibri" pitchFamily="34" charset="-120"/>
-                        </a:rPr>
-                        <a:t>[  ]</a:t>
+                        </a:defRPr>
+                      </a:pPr>
+                      <a:r>
+                        <a:t>0.8488</a:t>
                       </a:r>
-                      <a:endParaRPr lang="en-US" sz="1400" dirty="0">
-                        <a:latin typeface="Calibri" charset="0"/>
-                        <a:ea typeface="Calibri" charset="0"/>
-                        <a:cs typeface="Calibri" charset="0"/>
-                      </a:endParaRPr>
+                    </a:p>
+                  </a:txBody>
+                  <a:tcPr anchor="ctr">
+                    <a:lnL w="12700" cap="flat" cmpd="sng" algn="ctr">
+                      <a:solidFill>
+                        <a:srgbClr val="CFCBBD"/>
+                      </a:solidFill>
+                      <a:prstDash val="solid"/>
+                      <a:round/>
+                      <a:headEnd type="none" w="med" len="med"/>
+                      <a:tailEnd type="none" w="med" len="med"/>
+                    </a:lnL>
+                    <a:lnR w="12700" cap="flat" cmpd="sng" algn="ctr">
+                      <a:solidFill>
+                        <a:srgbClr val="CFCBBD"/>
+                      </a:solidFill>
+                      <a:prstDash val="solid"/>
+                      <a:round/>
+                      <a:headEnd type="none" w="med" len="med"/>
+                      <a:tailEnd type="none" w="med" len="med"/>
+                    </a:lnR>
+                    <a:lnT w="12700" cap="flat" cmpd="sng" algn="ctr">
+                      <a:solidFill>
+                        <a:srgbClr val="CFCBBD"/>
+                      </a:solidFill>
+                      <a:prstDash val="solid"/>
+                      <a:round/>
+                      <a:headEnd type="none" w="med" len="med"/>
+                      <a:tailEnd type="none" w="med" len="med"/>
+                    </a:lnT>
+                    <a:lnB w="12700" cap="flat" cmpd="sng" algn="ctr">
+                      <a:solidFill>
+                        <a:srgbClr val="CFCBBD"/>
+                      </a:solidFill>
+                      <a:prstDash val="solid"/>
+                      <a:round/>
+                      <a:headEnd type="none" w="med" len="med"/>
+                      <a:tailEnd type="none" w="med" len="med"/>
+                    </a:lnB>
+                    <a:solidFill>
+                      <a:srgbClr val="FFFFFF"/>
+                    </a:solidFill>
+                  </a:tcPr>
+                </a:tc>
+                <a:tc>
+                  <a:txBody>
+                    <a:bodyPr/>
+                    <a:lstStyle/>
+                    <a:p>
+                      <a:pPr>
+                        <a:defRPr sz="1100">
+                          <a:solidFill>
+                            <a:srgbClr val="0B1F3A"/>
+                          </a:solidFill>
+                        </a:defRPr>
+                      </a:pPr>
+                      <a:r>
+                        <a:t>0.6630</a:t>
+                      </a:r>
                     </a:p>
                   </a:txBody>
                   <a:tcPr anchor="ctr">
@@ -9639,74 +10517,11 @@
                     <a:p>
                       <a:pPr marL="0" indent="0" algn="ctr">
                         <a:buNone/>
-                      </a:pPr>
-                      <a:r>
-                        <a:rPr lang="en-US" sz="1400" dirty="0">
+                        <a:defRPr sz="1100">
                           <a:solidFill>
                             <a:srgbClr val="0B1F3A"/>
                           </a:solidFill>
-                          <a:latin typeface="Calibri" pitchFamily="34" charset="0"/>
-                          <a:ea typeface="Calibri" pitchFamily="34" charset="-122"/>
-                          <a:cs typeface="Calibri" pitchFamily="34" charset="-120"/>
-                        </a:rPr>
-                        <a:t>[  ]</a:t>
-                      </a:r>
-                      <a:endParaRPr lang="en-US" sz="1400" dirty="0">
-                        <a:latin typeface="Calibri" charset="0"/>
-                        <a:ea typeface="Calibri" charset="0"/>
-                        <a:cs typeface="Calibri" charset="0"/>
-                      </a:endParaRPr>
-                    </a:p>
-                  </a:txBody>
-                  <a:tcPr anchor="ctr">
-                    <a:lnL w="12700" cap="flat" cmpd="sng" algn="ctr">
-                      <a:solidFill>
-                        <a:srgbClr val="CFCBBD"/>
-                      </a:solidFill>
-                      <a:prstDash val="solid"/>
-                      <a:round/>
-                      <a:headEnd type="none" w="med" len="med"/>
-                      <a:tailEnd type="none" w="med" len="med"/>
-                    </a:lnL>
-                    <a:lnR w="12700" cap="flat" cmpd="sng" algn="ctr">
-                      <a:solidFill>
-                        <a:srgbClr val="CFCBBD"/>
-                      </a:solidFill>
-                      <a:prstDash val="solid"/>
-                      <a:round/>
-                      <a:headEnd type="none" w="med" len="med"/>
-                      <a:tailEnd type="none" w="med" len="med"/>
-                    </a:lnR>
-                    <a:lnT w="12700" cap="flat" cmpd="sng" algn="ctr">
-                      <a:solidFill>
-                        <a:srgbClr val="CFCBBD"/>
-                      </a:solidFill>
-                      <a:prstDash val="solid"/>
-                      <a:round/>
-                      <a:headEnd type="none" w="med" len="med"/>
-                      <a:tailEnd type="none" w="med" len="med"/>
-                    </a:lnT>
-                    <a:lnB w="12700" cap="flat" cmpd="sng" algn="ctr">
-                      <a:solidFill>
-                        <a:srgbClr val="CFCBBD"/>
-                      </a:solidFill>
-                      <a:prstDash val="solid"/>
-                      <a:round/>
-                      <a:headEnd type="none" w="med" len="med"/>
-                      <a:tailEnd type="none" w="med" len="med"/>
-                    </a:lnB>
-                    <a:solidFill>
-                      <a:srgbClr val="FFFFFF"/>
-                    </a:solidFill>
-                  </a:tcPr>
-                </a:tc>
-                <a:tc>
-                  <a:txBody>
-                    <a:bodyPr/>
-                    <a:lstStyle/>
-                    <a:p>
-                      <a:pPr marL="0" indent="0" algn="ctr">
-                        <a:buNone/>
+                        </a:defRPr>
                       </a:pPr>
                       <a:r>
                         <a:rPr lang="en-US" sz="1400" dirty="0">
@@ -9782,6 +10597,11 @@
                     <a:p>
                       <a:pPr marL="0" indent="0" algn="l">
                         <a:buNone/>
+                        <a:defRPr sz="1100">
+                          <a:solidFill>
+                            <a:srgbClr val="0B1F3A"/>
+                          </a:solidFill>
+                        </a:defRPr>
                       </a:pPr>
                       <a:r>
                         <a:rPr lang="en-US" sz="1300" b="1" dirty="0">
@@ -9848,25 +10668,75 @@
                     <a:bodyPr/>
                     <a:lstStyle/>
                     <a:p>
-                      <a:pPr marL="0" indent="0" algn="ctr">
-                        <a:buNone/>
-                      </a:pPr>
-                      <a:r>
-                        <a:rPr lang="en-US" sz="1400" dirty="0">
+                      <a:pPr>
+                        <a:defRPr sz="1100">
                           <a:solidFill>
                             <a:srgbClr val="0B1F3A"/>
                           </a:solidFill>
-                          <a:latin typeface="Calibri" pitchFamily="34" charset="0"/>
-                          <a:ea typeface="Calibri" pitchFamily="34" charset="-122"/>
-                          <a:cs typeface="Calibri" pitchFamily="34" charset="-120"/>
-                        </a:rPr>
-                        <a:t>[  ]</a:t>
+                        </a:defRPr>
+                      </a:pPr>
+                      <a:r>
+                        <a:t>0.8485</a:t>
                       </a:r>
-                      <a:endParaRPr lang="en-US" sz="1400" dirty="0">
-                        <a:latin typeface="Calibri" charset="0"/>
-                        <a:ea typeface="Calibri" charset="0"/>
-                        <a:cs typeface="Calibri" charset="0"/>
-                      </a:endParaRPr>
+                    </a:p>
+                  </a:txBody>
+                  <a:tcPr anchor="ctr">
+                    <a:lnL w="12700" cap="flat" cmpd="sng" algn="ctr">
+                      <a:solidFill>
+                        <a:srgbClr val="CFCBBD"/>
+                      </a:solidFill>
+                      <a:prstDash val="solid"/>
+                      <a:round/>
+                      <a:headEnd type="none" w="med" len="med"/>
+                      <a:tailEnd type="none" w="med" len="med"/>
+                    </a:lnL>
+                    <a:lnR w="12700" cap="flat" cmpd="sng" algn="ctr">
+                      <a:solidFill>
+                        <a:srgbClr val="CFCBBD"/>
+                      </a:solidFill>
+                      <a:prstDash val="solid"/>
+                      <a:round/>
+                      <a:headEnd type="none" w="med" len="med"/>
+                      <a:tailEnd type="none" w="med" len="med"/>
+                    </a:lnR>
+                    <a:lnT w="12700" cap="flat" cmpd="sng" algn="ctr">
+                      <a:solidFill>
+                        <a:srgbClr val="CFCBBD"/>
+                      </a:solidFill>
+                      <a:prstDash val="solid"/>
+                      <a:round/>
+                      <a:headEnd type="none" w="med" len="med"/>
+                      <a:tailEnd type="none" w="med" len="med"/>
+                    </a:lnT>
+                    <a:lnB w="12700" cap="flat" cmpd="sng" algn="ctr">
+                      <a:solidFill>
+                        <a:srgbClr val="CFCBBD"/>
+                      </a:solidFill>
+                      <a:prstDash val="solid"/>
+                      <a:round/>
+                      <a:headEnd type="none" w="med" len="med"/>
+                      <a:tailEnd type="none" w="med" len="med"/>
+                    </a:lnB>
+                    <a:solidFill>
+                      <a:srgbClr val="FFFFFF"/>
+                    </a:solidFill>
+                  </a:tcPr>
+                </a:tc>
+                <a:tc>
+                  <a:txBody>
+                    <a:bodyPr/>
+                    <a:lstStyle/>
+                    <a:p>
+                      <a:pPr>
+                        <a:defRPr sz="1100">
+                          <a:solidFill>
+                            <a:srgbClr val="0B1F3A"/>
+                          </a:solidFill>
+                        </a:defRPr>
+                      </a:pPr>
+                      <a:r>
+                        <a:t>0.6627</a:t>
+                      </a:r>
                     </a:p>
                   </a:txBody>
                   <a:tcPr anchor="ctr">
@@ -9918,74 +10788,11 @@
                     <a:p>
                       <a:pPr marL="0" indent="0" algn="ctr">
                         <a:buNone/>
-                      </a:pPr>
-                      <a:r>
-                        <a:rPr lang="en-US" sz="1400" dirty="0">
+                        <a:defRPr sz="1100">
                           <a:solidFill>
                             <a:srgbClr val="0B1F3A"/>
                           </a:solidFill>
-                          <a:latin typeface="Calibri" pitchFamily="34" charset="0"/>
-                          <a:ea typeface="Calibri" pitchFamily="34" charset="-122"/>
-                          <a:cs typeface="Calibri" pitchFamily="34" charset="-120"/>
-                        </a:rPr>
-                        <a:t>[  ]</a:t>
-                      </a:r>
-                      <a:endParaRPr lang="en-US" sz="1400" dirty="0">
-                        <a:latin typeface="Calibri" charset="0"/>
-                        <a:ea typeface="Calibri" charset="0"/>
-                        <a:cs typeface="Calibri" charset="0"/>
-                      </a:endParaRPr>
-                    </a:p>
-                  </a:txBody>
-                  <a:tcPr anchor="ctr">
-                    <a:lnL w="12700" cap="flat" cmpd="sng" algn="ctr">
-                      <a:solidFill>
-                        <a:srgbClr val="CFCBBD"/>
-                      </a:solidFill>
-                      <a:prstDash val="solid"/>
-                      <a:round/>
-                      <a:headEnd type="none" w="med" len="med"/>
-                      <a:tailEnd type="none" w="med" len="med"/>
-                    </a:lnL>
-                    <a:lnR w="12700" cap="flat" cmpd="sng" algn="ctr">
-                      <a:solidFill>
-                        <a:srgbClr val="CFCBBD"/>
-                      </a:solidFill>
-                      <a:prstDash val="solid"/>
-                      <a:round/>
-                      <a:headEnd type="none" w="med" len="med"/>
-                      <a:tailEnd type="none" w="med" len="med"/>
-                    </a:lnR>
-                    <a:lnT w="12700" cap="flat" cmpd="sng" algn="ctr">
-                      <a:solidFill>
-                        <a:srgbClr val="CFCBBD"/>
-                      </a:solidFill>
-                      <a:prstDash val="solid"/>
-                      <a:round/>
-                      <a:headEnd type="none" w="med" len="med"/>
-                      <a:tailEnd type="none" w="med" len="med"/>
-                    </a:lnT>
-                    <a:lnB w="12700" cap="flat" cmpd="sng" algn="ctr">
-                      <a:solidFill>
-                        <a:srgbClr val="CFCBBD"/>
-                      </a:solidFill>
-                      <a:prstDash val="solid"/>
-                      <a:round/>
-                      <a:headEnd type="none" w="med" len="med"/>
-                      <a:tailEnd type="none" w="med" len="med"/>
-                    </a:lnB>
-                    <a:solidFill>
-                      <a:srgbClr val="FFFFFF"/>
-                    </a:solidFill>
-                  </a:tcPr>
-                </a:tc>
-                <a:tc>
-                  <a:txBody>
-                    <a:bodyPr/>
-                    <a:lstStyle/>
-                    <a:p>
-                      <a:pPr marL="0" indent="0" algn="ctr">
-                        <a:buNone/>
+                        </a:defRPr>
                       </a:pPr>
                       <a:r>
                         <a:rPr lang="en-US" sz="1400" dirty="0">
@@ -10061,6 +10868,11 @@
                     <a:p>
                       <a:pPr marL="0" indent="0" algn="l">
                         <a:buNone/>
+                        <a:defRPr sz="1100" b="1">
+                          <a:solidFill>
+                            <a:srgbClr val="0F766E"/>
+                          </a:solidFill>
+                        </a:defRPr>
                       </a:pPr>
                       <a:r>
                         <a:rPr lang="en-US" sz="1300" b="1" dirty="0">
@@ -10127,25 +10939,75 @@
                     <a:bodyPr/>
                     <a:lstStyle/>
                     <a:p>
-                      <a:pPr marL="0" indent="0" algn="ctr">
-                        <a:buNone/>
+                      <a:pPr>
+                        <a:defRPr sz="1100" b="1">
+                          <a:solidFill>
+                            <a:srgbClr val="0F766E"/>
+                          </a:solidFill>
+                        </a:defRPr>
                       </a:pPr>
                       <a:r>
-                        <a:rPr lang="en-US" sz="1400" dirty="0">
+                        <a:t>0.8506</a:t>
+                      </a:r>
+                    </a:p>
+                  </a:txBody>
+                  <a:tcPr anchor="ctr">
+                    <a:lnL w="12700" cap="flat" cmpd="sng" algn="ctr">
+                      <a:solidFill>
+                        <a:srgbClr val="CFCBBD"/>
+                      </a:solidFill>
+                      <a:prstDash val="solid"/>
+                      <a:round/>
+                      <a:headEnd type="none" w="med" len="med"/>
+                      <a:tailEnd type="none" w="med" len="med"/>
+                    </a:lnL>
+                    <a:lnR w="12700" cap="flat" cmpd="sng" algn="ctr">
+                      <a:solidFill>
+                        <a:srgbClr val="CFCBBD"/>
+                      </a:solidFill>
+                      <a:prstDash val="solid"/>
+                      <a:round/>
+                      <a:headEnd type="none" w="med" len="med"/>
+                      <a:tailEnd type="none" w="med" len="med"/>
+                    </a:lnR>
+                    <a:lnT w="12700" cap="flat" cmpd="sng" algn="ctr">
+                      <a:solidFill>
+                        <a:srgbClr val="CFCBBD"/>
+                      </a:solidFill>
+                      <a:prstDash val="solid"/>
+                      <a:round/>
+                      <a:headEnd type="none" w="med" len="med"/>
+                      <a:tailEnd type="none" w="med" len="med"/>
+                    </a:lnT>
+                    <a:lnB w="12700" cap="flat" cmpd="sng" algn="ctr">
+                      <a:solidFill>
+                        <a:srgbClr val="CFCBBD"/>
+                      </a:solidFill>
+                      <a:prstDash val="solid"/>
+                      <a:round/>
+                      <a:headEnd type="none" w="med" len="med"/>
+                      <a:tailEnd type="none" w="med" len="med"/>
+                    </a:lnB>
+                    <a:solidFill>
+                      <a:srgbClr val="DDF1EE"/>
+                    </a:solidFill>
+                  </a:tcPr>
+                </a:tc>
+                <a:tc>
+                  <a:txBody>
+                    <a:bodyPr/>
+                    <a:lstStyle/>
+                    <a:p>
+                      <a:pPr>
+                        <a:defRPr sz="1100" b="1">
                           <a:solidFill>
-                            <a:srgbClr val="0B1F3A"/>
+                            <a:srgbClr val="0F766E"/>
                           </a:solidFill>
-                          <a:latin typeface="Calibri" pitchFamily="34" charset="0"/>
-                          <a:ea typeface="Calibri" pitchFamily="34" charset="-122"/>
-                          <a:cs typeface="Calibri" pitchFamily="34" charset="-120"/>
-                        </a:rPr>
-                        <a:t>[  ]</a:t>
+                        </a:defRPr>
+                      </a:pPr>
+                      <a:r>
+                        <a:t>0.6645</a:t>
                       </a:r>
-                      <a:endParaRPr lang="en-US" sz="1400" dirty="0">
-                        <a:latin typeface="Calibri" charset="0"/>
-                        <a:ea typeface="Calibri" charset="0"/>
-                        <a:cs typeface="Calibri" charset="0"/>
-                      </a:endParaRPr>
                     </a:p>
                   </a:txBody>
                   <a:tcPr anchor="ctr">
@@ -10197,74 +11059,11 @@
                     <a:p>
                       <a:pPr marL="0" indent="0" algn="ctr">
                         <a:buNone/>
-                      </a:pPr>
-                      <a:r>
-                        <a:rPr lang="en-US" sz="1400" dirty="0">
+                        <a:defRPr sz="1100" b="1">
                           <a:solidFill>
-                            <a:srgbClr val="0B1F3A"/>
+                            <a:srgbClr val="0F766E"/>
                           </a:solidFill>
-                          <a:latin typeface="Calibri" pitchFamily="34" charset="0"/>
-                          <a:ea typeface="Calibri" pitchFamily="34" charset="-122"/>
-                          <a:cs typeface="Calibri" pitchFamily="34" charset="-120"/>
-                        </a:rPr>
-                        <a:t>[  ]</a:t>
-                      </a:r>
-                      <a:endParaRPr lang="en-US" sz="1400" dirty="0">
-                        <a:latin typeface="Calibri" charset="0"/>
-                        <a:ea typeface="Calibri" charset="0"/>
-                        <a:cs typeface="Calibri" charset="0"/>
-                      </a:endParaRPr>
-                    </a:p>
-                  </a:txBody>
-                  <a:tcPr anchor="ctr">
-                    <a:lnL w="12700" cap="flat" cmpd="sng" algn="ctr">
-                      <a:solidFill>
-                        <a:srgbClr val="CFCBBD"/>
-                      </a:solidFill>
-                      <a:prstDash val="solid"/>
-                      <a:round/>
-                      <a:headEnd type="none" w="med" len="med"/>
-                      <a:tailEnd type="none" w="med" len="med"/>
-                    </a:lnL>
-                    <a:lnR w="12700" cap="flat" cmpd="sng" algn="ctr">
-                      <a:solidFill>
-                        <a:srgbClr val="CFCBBD"/>
-                      </a:solidFill>
-                      <a:prstDash val="solid"/>
-                      <a:round/>
-                      <a:headEnd type="none" w="med" len="med"/>
-                      <a:tailEnd type="none" w="med" len="med"/>
-                    </a:lnR>
-                    <a:lnT w="12700" cap="flat" cmpd="sng" algn="ctr">
-                      <a:solidFill>
-                        <a:srgbClr val="CFCBBD"/>
-                      </a:solidFill>
-                      <a:prstDash val="solid"/>
-                      <a:round/>
-                      <a:headEnd type="none" w="med" len="med"/>
-                      <a:tailEnd type="none" w="med" len="med"/>
-                    </a:lnT>
-                    <a:lnB w="12700" cap="flat" cmpd="sng" algn="ctr">
-                      <a:solidFill>
-                        <a:srgbClr val="CFCBBD"/>
-                      </a:solidFill>
-                      <a:prstDash val="solid"/>
-                      <a:round/>
-                      <a:headEnd type="none" w="med" len="med"/>
-                      <a:tailEnd type="none" w="med" len="med"/>
-                    </a:lnB>
-                    <a:solidFill>
-                      <a:srgbClr val="DDF1EE"/>
-                    </a:solidFill>
-                  </a:tcPr>
-                </a:tc>
-                <a:tc>
-                  <a:txBody>
-                    <a:bodyPr/>
-                    <a:lstStyle/>
-                    <a:p>
-                      <a:pPr marL="0" indent="0" algn="ctr">
-                        <a:buNone/>
+                        </a:defRPr>
                       </a:pPr>
                       <a:r>
                         <a:rPr lang="en-US" sz="1400" dirty="0">
@@ -10340,6 +11139,11 @@
                     <a:p>
                       <a:pPr marL="0" indent="0" algn="l">
                         <a:buNone/>
+                        <a:defRPr sz="1100">
+                          <a:solidFill>
+                            <a:srgbClr val="0B1F3A"/>
+                          </a:solidFill>
+                        </a:defRPr>
                       </a:pPr>
                       <a:r>
                         <a:rPr lang="en-US" sz="1300" b="1" dirty="0">
@@ -10406,25 +11210,75 @@
                     <a:bodyPr/>
                     <a:lstStyle/>
                     <a:p>
-                      <a:pPr marL="0" indent="0" algn="ctr">
-                        <a:buNone/>
-                      </a:pPr>
-                      <a:r>
-                        <a:rPr lang="en-US" sz="1400" dirty="0">
+                      <a:pPr>
+                        <a:defRPr sz="1100">
                           <a:solidFill>
                             <a:srgbClr val="0B1F3A"/>
                           </a:solidFill>
-                          <a:latin typeface="Calibri" pitchFamily="34" charset="0"/>
-                          <a:ea typeface="Calibri" pitchFamily="34" charset="-122"/>
-                          <a:cs typeface="Calibri" pitchFamily="34" charset="-120"/>
-                        </a:rPr>
-                        <a:t>[  ]</a:t>
+                        </a:defRPr>
+                      </a:pPr>
+                      <a:r>
+                        <a:t>0.8506</a:t>
                       </a:r>
-                      <a:endParaRPr lang="en-US" sz="1400" dirty="0">
-                        <a:latin typeface="Calibri" charset="0"/>
-                        <a:ea typeface="Calibri" charset="0"/>
-                        <a:cs typeface="Calibri" charset="0"/>
-                      </a:endParaRPr>
+                    </a:p>
+                  </a:txBody>
+                  <a:tcPr anchor="ctr">
+                    <a:lnL w="12700" cap="flat" cmpd="sng" algn="ctr">
+                      <a:solidFill>
+                        <a:srgbClr val="CFCBBD"/>
+                      </a:solidFill>
+                      <a:prstDash val="solid"/>
+                      <a:round/>
+                      <a:headEnd type="none" w="med" len="med"/>
+                      <a:tailEnd type="none" w="med" len="med"/>
+                    </a:lnL>
+                    <a:lnR w="12700" cap="flat" cmpd="sng" algn="ctr">
+                      <a:solidFill>
+                        <a:srgbClr val="CFCBBD"/>
+                      </a:solidFill>
+                      <a:prstDash val="solid"/>
+                      <a:round/>
+                      <a:headEnd type="none" w="med" len="med"/>
+                      <a:tailEnd type="none" w="med" len="med"/>
+                    </a:lnR>
+                    <a:lnT w="12700" cap="flat" cmpd="sng" algn="ctr">
+                      <a:solidFill>
+                        <a:srgbClr val="CFCBBD"/>
+                      </a:solidFill>
+                      <a:prstDash val="solid"/>
+                      <a:round/>
+                      <a:headEnd type="none" w="med" len="med"/>
+                      <a:tailEnd type="none" w="med" len="med"/>
+                    </a:lnT>
+                    <a:lnB w="12700" cap="flat" cmpd="sng" algn="ctr">
+                      <a:solidFill>
+                        <a:srgbClr val="CFCBBD"/>
+                      </a:solidFill>
+                      <a:prstDash val="solid"/>
+                      <a:round/>
+                      <a:headEnd type="none" w="med" len="med"/>
+                      <a:tailEnd type="none" w="med" len="med"/>
+                    </a:lnB>
+                    <a:solidFill>
+                      <a:srgbClr val="FFFFFF"/>
+                    </a:solidFill>
+                  </a:tcPr>
+                </a:tc>
+                <a:tc>
+                  <a:txBody>
+                    <a:bodyPr/>
+                    <a:lstStyle/>
+                    <a:p>
+                      <a:pPr>
+                        <a:defRPr sz="1100">
+                          <a:solidFill>
+                            <a:srgbClr val="0B1F3A"/>
+                          </a:solidFill>
+                        </a:defRPr>
+                      </a:pPr>
+                      <a:r>
+                        <a:t>0.6660</a:t>
+                      </a:r>
                     </a:p>
                   </a:txBody>
                   <a:tcPr anchor="ctr">
@@ -10476,74 +11330,11 @@
                     <a:p>
                       <a:pPr marL="0" indent="0" algn="ctr">
                         <a:buNone/>
-                      </a:pPr>
-                      <a:r>
-                        <a:rPr lang="en-US" sz="1400" dirty="0">
+                        <a:defRPr sz="1100">
                           <a:solidFill>
                             <a:srgbClr val="0B1F3A"/>
                           </a:solidFill>
-                          <a:latin typeface="Calibri" pitchFamily="34" charset="0"/>
-                          <a:ea typeface="Calibri" pitchFamily="34" charset="-122"/>
-                          <a:cs typeface="Calibri" pitchFamily="34" charset="-120"/>
-                        </a:rPr>
-                        <a:t>[  ]</a:t>
-                      </a:r>
-                      <a:endParaRPr lang="en-US" sz="1400" dirty="0">
-                        <a:latin typeface="Calibri" charset="0"/>
-                        <a:ea typeface="Calibri" charset="0"/>
-                        <a:cs typeface="Calibri" charset="0"/>
-                      </a:endParaRPr>
-                    </a:p>
-                  </a:txBody>
-                  <a:tcPr anchor="ctr">
-                    <a:lnL w="12700" cap="flat" cmpd="sng" algn="ctr">
-                      <a:solidFill>
-                        <a:srgbClr val="CFCBBD"/>
-                      </a:solidFill>
-                      <a:prstDash val="solid"/>
-                      <a:round/>
-                      <a:headEnd type="none" w="med" len="med"/>
-                      <a:tailEnd type="none" w="med" len="med"/>
-                    </a:lnL>
-                    <a:lnR w="12700" cap="flat" cmpd="sng" algn="ctr">
-                      <a:solidFill>
-                        <a:srgbClr val="CFCBBD"/>
-                      </a:solidFill>
-                      <a:prstDash val="solid"/>
-                      <a:round/>
-                      <a:headEnd type="none" w="med" len="med"/>
-                      <a:tailEnd type="none" w="med" len="med"/>
-                    </a:lnR>
-                    <a:lnT w="12700" cap="flat" cmpd="sng" algn="ctr">
-                      <a:solidFill>
-                        <a:srgbClr val="CFCBBD"/>
-                      </a:solidFill>
-                      <a:prstDash val="solid"/>
-                      <a:round/>
-                      <a:headEnd type="none" w="med" len="med"/>
-                      <a:tailEnd type="none" w="med" len="med"/>
-                    </a:lnT>
-                    <a:lnB w="12700" cap="flat" cmpd="sng" algn="ctr">
-                      <a:solidFill>
-                        <a:srgbClr val="CFCBBD"/>
-                      </a:solidFill>
-                      <a:prstDash val="solid"/>
-                      <a:round/>
-                      <a:headEnd type="none" w="med" len="med"/>
-                      <a:tailEnd type="none" w="med" len="med"/>
-                    </a:lnB>
-                    <a:solidFill>
-                      <a:srgbClr val="FFFFFF"/>
-                    </a:solidFill>
-                  </a:tcPr>
-                </a:tc>
-                <a:tc>
-                  <a:txBody>
-                    <a:bodyPr/>
-                    <a:lstStyle/>
-                    <a:p>
-                      <a:pPr marL="0" indent="0" algn="ctr">
-                        <a:buNone/>
+                        </a:defRPr>
                       </a:pPr>
                       <a:r>
                         <a:rPr lang="en-US" sz="1400" dirty="0">
@@ -10643,6 +11434,10 @@
             <a:prstDash val="solid"/>
           </a:ln>
         </p:spPr>
+        <p:txBody>
+          <a:bodyPr/>
+          <a:p/>
+        </p:txBody>
       </p:sp>
       <p:sp>
         <p:nvSpPr>
@@ -10665,21 +11460,16 @@
           <a:bodyPr wrap="square" lIns="0" tIns="0" rIns="0" bIns="0" rtlCol="0" anchor="ctr"/>
           <a:lstStyle/>
           <a:p>
-            <a:pPr marL="0" indent="0">
-              <a:buNone/>
-            </a:pPr>
-            <a:r>
-              <a:rPr lang="en-US" sz="2200" b="1" dirty="0">
+            <a:pPr>
+              <a:defRPr sz="2800" b="1">
                 <a:solidFill>
                   <a:srgbClr val="0F766E"/>
                 </a:solidFill>
-                <a:latin typeface="Courier New" pitchFamily="34" charset="0"/>
-                <a:ea typeface="Courier New" pitchFamily="34" charset="-122"/>
-                <a:cs typeface="Courier New" pitchFamily="34" charset="-120"/>
-              </a:rPr>
-              <a:t>[ X ] / 15</a:t>
-            </a:r>
-            <a:endParaRPr lang="en-US" sz="2200" dirty="0"/>
+              </a:defRPr>
+            </a:pPr>
+            <a:r>
+              <a:t>15 / 15</a:t>
+            </a:r>
           </a:p>
         </p:txBody>
       </p:sp>
@@ -10750,6 +11540,10 @@
             <a:prstDash val="solid"/>
           </a:ln>
         </p:spPr>
+        <p:txBody>
+          <a:bodyPr/>
+          <a:p/>
+        </p:txBody>
       </p:sp>
       <p:sp>
         <p:nvSpPr>
@@ -10772,21 +11566,16 @@
           <a:bodyPr wrap="square" lIns="0" tIns="0" rIns="0" bIns="0" rtlCol="0" anchor="ctr"/>
           <a:lstStyle/>
           <a:p>
-            <a:pPr marL="0" indent="0">
-              <a:buNone/>
-            </a:pPr>
-            <a:r>
-              <a:rPr lang="en-US" sz="2200" b="1" dirty="0">
+            <a:pPr>
+              <a:defRPr sz="2400" b="1">
                 <a:solidFill>
                   <a:srgbClr val="B45309"/>
                 </a:solidFill>
-                <a:latin typeface="Courier New" pitchFamily="34" charset="0"/>
-                <a:ea typeface="Courier New" pitchFamily="34" charset="-122"/>
-                <a:cs typeface="Courier New" pitchFamily="34" charset="-120"/>
-              </a:rPr>
-              <a:t>[ Y ]</a:t>
-            </a:r>
-            <a:endParaRPr lang="en-US" sz="2200" dirty="0"/>
+              </a:defRPr>
+            </a:pPr>
+            <a:r>
+              <a:t>Optimal</a:t>
+            </a:r>
           </a:p>
         </p:txBody>
       </p:sp>
@@ -10857,6 +11646,10 @@
             <a:prstDash val="solid"/>
           </a:ln>
         </p:spPr>
+        <p:txBody>
+          <a:bodyPr/>
+          <a:p/>
+        </p:txBody>
       </p:sp>
       <p:sp>
         <p:nvSpPr>
@@ -10962,6 +11755,10 @@
             <a:prstDash val="dash"/>
           </a:ln>
         </p:spPr>
+        <p:txBody>
+          <a:bodyPr/>
+          <a:p/>
+        </p:txBody>
       </p:sp>
       <p:sp>
         <p:nvSpPr>
@@ -10983,23 +11780,7 @@
         <p:txBody>
           <a:bodyPr wrap="square" lIns="127000" tIns="127000" rIns="127000" bIns="127000" rtlCol="0" anchor="ctr"/>
           <a:lstStyle/>
-          <a:p>
-            <a:pPr marL="0" indent="0" algn="ctr">
-              <a:buNone/>
-            </a:pPr>
-            <a:r>
-              <a:rPr lang="en-US" sz="1400" dirty="0">
-                <a:solidFill>
-                  <a:srgbClr val="1D4ED8"/>
-                </a:solidFill>
-                <a:latin typeface="Courier New" pitchFamily="34" charset="0"/>
-                <a:ea typeface="Courier New" pitchFamily="34" charset="-122"/>
-                <a:cs typeface="Courier New" pitchFamily="34" charset="-120"/>
-              </a:rPr>
-              <a:t>INSERT CHART: ROC-AUC and PR-AUC by run, with the convergence-brake line marked</a:t>
-            </a:r>
-            <a:endParaRPr lang="en-US" sz="1400" dirty="0"/>
-          </a:p>
+          <a:p/>
         </p:txBody>
       </p:sp>
       <p:sp>
@@ -11050,6 +11831,30 @@
           </a:p>
         </p:txBody>
       </p:sp>
+      <p:pic>
+        <p:nvPicPr>
+          <p:cNvPr id="26" name="Picture 25" descr="chart_trajectory.png"/>
+          <p:cNvPicPr>
+            <a:picLocks noChangeAspect="1"/>
+          </p:cNvPicPr>
+          <p:nvPr/>
+        </p:nvPicPr>
+        <p:blipFill>
+          <a:blip r:embed="rId3"/>
+          <a:stretch>
+            <a:fillRect/>
+          </a:stretch>
+        </p:blipFill>
+        <p:spPr>
+          <a:xfrm>
+            <a:off x="548640" y="4846320"/>
+            <a:ext cx="11109960" cy="1280160"/>
+          </a:xfrm>
+          <a:prstGeom prst="rect">
+            <a:avLst/>
+          </a:prstGeom>
+        </p:spPr>
+      </p:pic>
     </p:spTree>
   </p:cSld>
   <p:clrMapOvr>
@@ -11179,6 +11984,10 @@
             <a:prstDash val="dash"/>
           </a:ln>
         </p:spPr>
+        <p:txBody>
+          <a:bodyPr/>
+          <a:p/>
+        </p:txBody>
       </p:sp>
       <p:sp>
         <p:nvSpPr>
@@ -11200,40 +12009,7 @@
         <p:txBody>
           <a:bodyPr wrap="square" lIns="127000" tIns="127000" rIns="127000" bIns="127000" rtlCol="0" anchor="ctr"/>
           <a:lstStyle/>
-          <a:p>
-            <a:pPr marL="0" indent="0" algn="ctr">
-              <a:buNone/>
-            </a:pPr>
-            <a:r>
-              <a:rPr lang="en-US" sz="1400" dirty="0">
-                <a:solidFill>
-                  <a:srgbClr val="1D4ED8"/>
-                </a:solidFill>
-                <a:latin typeface="Courier New" pitchFamily="34" charset="0"/>
-                <a:ea typeface="Courier New" pitchFamily="34" charset="-122"/>
-                <a:cs typeface="Courier New" pitchFamily="34" charset="-120"/>
-              </a:rPr>
-              <a:t>SCREENSHOT</a:t>
-            </a:r>
-            <a:endParaRPr lang="en-US" sz="1400" dirty="0"/>
-          </a:p>
-          <a:p>
-            <a:pPr marL="0" indent="0" algn="ctr">
-              <a:buNone/>
-            </a:pPr>
-            <a:r>
-              <a:rPr lang="en-US" sz="1400" dirty="0">
-                <a:solidFill>
-                  <a:srgbClr val="1D4ED8"/>
-                </a:solidFill>
-                <a:latin typeface="Courier New" pitchFamily="34" charset="0"/>
-                <a:ea typeface="Courier New" pitchFamily="34" charset="-122"/>
-                <a:cs typeface="Courier New" pitchFamily="34" charset="-120"/>
-              </a:rPr>
-              <a:t>Live dashboard: budget gauge, reasoning terminal, metric charts</a:t>
-            </a:r>
-            <a:endParaRPr lang="en-US" sz="1400" dirty="0"/>
-          </a:p>
+          <a:p/>
         </p:txBody>
       </p:sp>
       <p:sp>
@@ -11262,6 +12038,10 @@
             <a:prstDash val="dash"/>
           </a:ln>
         </p:spPr>
+        <p:txBody>
+          <a:bodyPr/>
+          <a:p/>
+        </p:txBody>
       </p:sp>
       <p:sp>
         <p:nvSpPr>
@@ -11283,40 +12063,7 @@
         <p:txBody>
           <a:bodyPr wrap="square" lIns="127000" tIns="127000" rIns="127000" bIns="127000" rtlCol="0" anchor="ctr"/>
           <a:lstStyle/>
-          <a:p>
-            <a:pPr marL="0" indent="0" algn="ctr">
-              <a:buNone/>
-            </a:pPr>
-            <a:r>
-              <a:rPr lang="en-US" sz="1400" dirty="0">
-                <a:solidFill>
-                  <a:srgbClr val="1D4ED8"/>
-                </a:solidFill>
-                <a:latin typeface="Courier New" pitchFamily="34" charset="0"/>
-                <a:ea typeface="Courier New" pitchFamily="34" charset="-122"/>
-                <a:cs typeface="Courier New" pitchFamily="34" charset="-120"/>
-              </a:rPr>
-              <a:t>SCREENSHOT</a:t>
-            </a:r>
-            <a:endParaRPr lang="en-US" sz="1400" dirty="0"/>
-          </a:p>
-          <a:p>
-            <a:pPr marL="0" indent="0" algn="ctr">
-              <a:buNone/>
-            </a:pPr>
-            <a:r>
-              <a:rPr lang="en-US" sz="1400" dirty="0">
-                <a:solidFill>
-                  <a:srgbClr val="1D4ED8"/>
-                </a:solidFill>
-                <a:latin typeface="Courier New" pitchFamily="34" charset="0"/>
-                <a:ea typeface="Courier New" pitchFamily="34" charset="-122"/>
-                <a:cs typeface="Courier New" pitchFamily="34" charset="-120"/>
-              </a:rPr>
-              <a:t>Hyperparameter table with champion run highlighted</a:t>
-            </a:r>
-            <a:endParaRPr lang="en-US" sz="1400" dirty="0"/>
-          </a:p>
+          <a:p/>
         </p:txBody>
       </p:sp>
       <p:sp>
@@ -11347,6 +12094,10 @@
             <a:prstDash val="solid"/>
           </a:ln>
         </p:spPr>
+        <p:txBody>
+          <a:bodyPr/>
+          <a:p/>
+        </p:txBody>
       </p:sp>
       <p:sp>
         <p:nvSpPr>
@@ -11408,21 +12159,16 @@
           <a:bodyPr wrap="square" lIns="0" tIns="0" rIns="0" bIns="0" rtlCol="0" anchor="t"/>
           <a:lstStyle/>
           <a:p>
-            <a:pPr marL="0" indent="0">
-              <a:buNone/>
-            </a:pPr>
-            <a:r>
-              <a:rPr lang="en-US" sz="1300" i="1" dirty="0">
-                <a:solidFill>
-                  <a:srgbClr val="0B1F3A"/>
-                </a:solidFill>
-                <a:latin typeface="Courier New" pitchFamily="34" charset="0"/>
-                <a:ea typeface="Courier New" pitchFamily="34" charset="-122"/>
-                <a:cs typeface="Courier New" pitchFamily="34" charset="-120"/>
-              </a:rPr>
-              <a:t>"Overfit gap is 0.0527. Reducing depth to 5, raising L2 to 9, and setting scale_pos_weight to 1.68 to lift PR-AUC."</a:t>
-            </a:r>
-            <a:endParaRPr lang="en-US" sz="1300" dirty="0"/>
+            <a:pPr>
+              <a:defRPr sz="1050" i="1">
+                <a:solidFill>
+                  <a:srgbClr val="0F766E"/>
+                </a:solidFill>
+              </a:defRPr>
+            </a:pPr>
+            <a:r>
+              <a:t>"Generalization gap prioritized: pruned tree depth to 5 and scaled L2 regularization to 11.72 with balanced class weights. Overfitting index dropped by 38.9% (11.27% -&gt; 6.88%), securing Champion Model #12 with 0.8506 Val ROC-AUC and 0.8443 Holdout ROC-AUC."</a:t>
+            </a:r>
           </a:p>
         </p:txBody>
       </p:sp>
@@ -11452,6 +12198,10 @@
             <a:prstDash val="dash"/>
           </a:ln>
         </p:spPr>
+        <p:txBody>
+          <a:bodyPr/>
+          <a:p/>
+        </p:txBody>
       </p:sp>
       <p:sp>
         <p:nvSpPr>
@@ -11476,36 +12226,40 @@
           <a:p>
             <a:pPr marL="0" indent="0" algn="ctr">
               <a:buNone/>
-            </a:pPr>
-            <a:r>
-              <a:rPr lang="en-US" sz="1400" dirty="0">
-                <a:solidFill>
-                  <a:srgbClr val="1D4ED8"/>
-                </a:solidFill>
-                <a:latin typeface="Courier New" pitchFamily="34" charset="0"/>
-                <a:ea typeface="Courier New" pitchFamily="34" charset="-122"/>
-                <a:cs typeface="Courier New" pitchFamily="34" charset="-120"/>
-              </a:rPr>
-              <a:t>SAMPLE PREDICTION</a:t>
+              <a:defRPr b="1" sz="1000">
+                <a:solidFill>
+                  <a:srgbClr val="0B1F3A"/>
+                </a:solidFill>
+              </a:defRPr>
+            </a:pPr>
+            <a:r>
+              <a:t>SAMPLE PREDICTIONS (SEALED HOLDOUT)</a:t>
             </a:r>
             <a:endParaRPr lang="en-US" sz="1400" dirty="0"/>
           </a:p>
           <a:p>
-            <a:pPr marL="0" indent="0" algn="ctr">
-              <a:buNone/>
-            </a:pPr>
-            <a:r>
-              <a:rPr lang="en-US" sz="1400" dirty="0">
-                <a:solidFill>
-                  <a:srgbClr val="1D4ED8"/>
-                </a:solidFill>
-                <a:latin typeface="Courier New" pitchFamily="34" charset="0"/>
-                <a:ea typeface="Courier New" pitchFamily="34" charset="-122"/>
-                <a:cs typeface="Courier New" pitchFamily="34" charset="-120"/>
-              </a:rPr>
-              <a:t>Customer X: [ ]% churn risk</a:t>
-            </a:r>
-            <a:endParaRPr lang="en-US" sz="1400" dirty="0"/>
+            <a:pPr>
+              <a:defRPr sz="950" b="1">
+                <a:solidFill>
+                  <a:srgbClr val="DC2626"/>
+                </a:solidFill>
+              </a:defRPr>
+            </a:pPr>
+            <a:r>
+              <a:t>• CUST_00001: 89.3% churn risk [HIGH HAZARD]</a:t>
+            </a:r>
+          </a:p>
+          <a:p>
+            <a:pPr>
+              <a:defRPr sz="950" b="1">
+                <a:solidFill>
+                  <a:srgbClr val="0F766E"/>
+                </a:solidFill>
+              </a:defRPr>
+            </a:pPr>
+            <a:r>
+              <a:t>• CUST_00004: 1.8% churn risk [LOYAL / STABLE]</a:t>
+            </a:r>
           </a:p>
         </p:txBody>
       </p:sp>
@@ -11557,6 +12311,54 @@
           </a:p>
         </p:txBody>
       </p:sp>
+      <p:pic>
+        <p:nvPicPr>
+          <p:cNvPr id="26" name="Picture 25" descr="dashboard_preview.png"/>
+          <p:cNvPicPr>
+            <a:picLocks noChangeAspect="1"/>
+          </p:cNvPicPr>
+          <p:nvPr/>
+        </p:nvPicPr>
+        <p:blipFill>
+          <a:blip r:embed="rId3"/>
+          <a:stretch>
+            <a:fillRect/>
+          </a:stretch>
+        </p:blipFill>
+        <p:spPr>
+          <a:xfrm>
+            <a:off x="548640" y="1280160"/>
+            <a:ext cx="5486400" cy="3017520"/>
+          </a:xfrm>
+          <a:prstGeom prst="rect">
+            <a:avLst/>
+          </a:prstGeom>
+        </p:spPr>
+      </p:pic>
+      <p:pic>
+        <p:nvPicPr>
+          <p:cNvPr id="27" name="Picture 26" descr="hyperparameters_preview.png"/>
+          <p:cNvPicPr>
+            <a:picLocks noChangeAspect="1"/>
+          </p:cNvPicPr>
+          <p:nvPr/>
+        </p:nvPicPr>
+        <p:blipFill>
+          <a:blip r:embed="rId4"/>
+          <a:stretch>
+            <a:fillRect/>
+          </a:stretch>
+        </p:blipFill>
+        <p:spPr>
+          <a:xfrm>
+            <a:off x="6172200" y="1280160"/>
+            <a:ext cx="5486400" cy="3017520"/>
+          </a:xfrm>
+          <a:prstGeom prst="rect">
+            <a:avLst/>
+          </a:prstGeom>
+        </p:spPr>
+      </p:pic>
     </p:spTree>
   </p:cSld>
   <p:clrMapOvr>

</xml_diff>

<commit_message>
style(ppt): restore exact template design with cream background across all slides
</commit_message>
<xml_diff>
--- a/ppt/QUANTA_PPT.pptx
+++ b/ppt/QUANTA_PPT.pptx
@@ -1088,11 +1088,22 @@
 
 <file path=ppt/slideLayouts/slideLayout1.xml><?xml version="1.0" encoding="utf-8"?>
 <p:sldLayout xmlns:a="http://schemas.openxmlformats.org/drawingml/2006/main" xmlns:r="http://schemas.openxmlformats.org/officeDocument/2006/relationships" xmlns:p="http://schemas.openxmlformats.org/presentationml/2006/main" preserve="1">
+  <p:bg>
+    <p:bgPr>
+      <a:solidFill>
+        <a:srgbClr val="FAF6EE"/>
+      </a:solidFill>
+      <a:effectLst/>
+    </p:bgPr>
+  </p:bg>
   <p:cSld name="DEFAULT">
     <p:bg>
-      <p:bgRef idx="1001">
-        <a:schemeClr val="bg1"/>
-      </p:bgRef>
+      <p:bgPr>
+        <a:solidFill>
+          <a:srgbClr val="FAF6EE"/>
+        </a:solidFill>
+        <a:effectLst/>
+      </p:bgPr>
     </p:bg>
     <p:spTree>
       <p:nvGrpSpPr>
@@ -1118,18 +1129,20 @@
 
 <file path=ppt/slideLayouts/slideLayout2.xml><?xml version="1.0" encoding="utf-8"?>
 <p:sldLayout xmlns:a="http://schemas.openxmlformats.org/drawingml/2006/main" xmlns:r="http://schemas.openxmlformats.org/officeDocument/2006/relationships" xmlns:p="http://schemas.openxmlformats.org/presentationml/2006/main" preserve="1">
+  <p:bg>
+    <p:bgPr>
+      <a:solidFill>
+        <a:srgbClr val="FAF6EE"/>
+      </a:solidFill>
+      <a:effectLst/>
+    </p:bgPr>
+  </p:bg>
   <p:cSld name="QUANTA_CONTENT">
     <p:bg>
       <p:bgPr>
-        <a:blipFill dpi="0" rotWithShape="1">
-          <a:blip r:embed="rId2">
-            <a:lum/>
-          </a:blip>
-          <a:srcRect/>
-          <a:stretch>
-            <a:fillRect/>
-          </a:stretch>
-        </a:blipFill>
+        <a:solidFill>
+          <a:srgbClr val="FAF6EE"/>
+        </a:solidFill>
         <a:effectLst/>
       </p:bgPr>
     </p:bg>
@@ -1244,11 +1257,22 @@
 
 <file path=ppt/slideMasters/slideMaster1.xml><?xml version="1.0" encoding="utf-8"?>
 <p:sldMaster xmlns:a="http://schemas.openxmlformats.org/drawingml/2006/main" xmlns:r="http://schemas.openxmlformats.org/officeDocument/2006/relationships" xmlns:p="http://schemas.openxmlformats.org/presentationml/2006/main">
+  <p:bg>
+    <p:bgPr>
+      <a:solidFill>
+        <a:srgbClr val="FAF6EE"/>
+      </a:solidFill>
+      <a:effectLst/>
+    </p:bgPr>
+  </p:bg>
   <p:cSld>
     <p:bg>
-      <p:bgRef idx="1001">
-        <a:schemeClr val="bg1"/>
-      </p:bgRef>
+      <p:bgPr>
+        <a:solidFill>
+          <a:srgbClr val="FAF6EE"/>
+        </a:solidFill>
+        <a:effectLst/>
+      </p:bgPr>
     </p:bg>
     <p:spTree>
       <p:nvGrpSpPr>
@@ -1575,7 +1599,23 @@
 
 <file path=ppt/slides/slide1.xml><?xml version="1.0" encoding="utf-8"?>
 <p:sld xmlns:a="http://schemas.openxmlformats.org/drawingml/2006/main" xmlns:r="http://schemas.openxmlformats.org/officeDocument/2006/relationships" xmlns:p="http://schemas.openxmlformats.org/presentationml/2006/main">
+  <p:bg>
+    <p:bgPr>
+      <a:solidFill>
+        <a:srgbClr val="FAF6EE"/>
+      </a:solidFill>
+      <a:effectLst/>
+    </p:bgPr>
+  </p:bg>
   <p:cSld name="Slide 1">
+    <p:bg>
+      <p:bgPr>
+        <a:solidFill>
+          <a:srgbClr val="FAF6EE"/>
+        </a:solidFill>
+        <a:effectLst/>
+      </p:bgPr>
+    </p:bg>
     <p:spTree>
       <p:nvGrpSpPr>
         <p:cNvPr id="1" name=""/>
@@ -2154,7 +2194,23 @@
 
 <file path=ppt/slides/slide10.xml><?xml version="1.0" encoding="utf-8"?>
 <p:sld xmlns:a="http://schemas.openxmlformats.org/drawingml/2006/main" xmlns:r="http://schemas.openxmlformats.org/officeDocument/2006/relationships" xmlns:p="http://schemas.openxmlformats.org/presentationml/2006/main">
+  <p:bg>
+    <p:bgPr>
+      <a:solidFill>
+        <a:srgbClr val="FAF6EE"/>
+      </a:solidFill>
+      <a:effectLst/>
+    </p:bgPr>
+  </p:bg>
   <p:cSld name="Slide 10">
+    <p:bg>
+      <p:bgPr>
+        <a:solidFill>
+          <a:srgbClr val="FAF6EE"/>
+        </a:solidFill>
+        <a:effectLst/>
+      </p:bgPr>
+    </p:bg>
     <p:spTree>
       <p:nvGrpSpPr>
         <p:cNvPr id="1" name=""/>
@@ -2797,7 +2853,23 @@
 
 <file path=ppt/slides/slide2.xml><?xml version="1.0" encoding="utf-8"?>
 <p:sld xmlns:a="http://schemas.openxmlformats.org/drawingml/2006/main" xmlns:r="http://schemas.openxmlformats.org/officeDocument/2006/relationships" xmlns:p="http://schemas.openxmlformats.org/presentationml/2006/main">
+  <p:bg>
+    <p:bgPr>
+      <a:solidFill>
+        <a:srgbClr val="FAF6EE"/>
+      </a:solidFill>
+      <a:effectLst/>
+    </p:bgPr>
+  </p:bg>
   <p:cSld name="Slide 2">
+    <p:bg>
+      <p:bgPr>
+        <a:solidFill>
+          <a:srgbClr val="FAF6EE"/>
+        </a:solidFill>
+        <a:effectLst/>
+      </p:bgPr>
+    </p:bg>
     <p:spTree>
       <p:nvGrpSpPr>
         <p:cNvPr id="1" name=""/>
@@ -3575,7 +3647,23 @@
 
 <file path=ppt/slides/slide3.xml><?xml version="1.0" encoding="utf-8"?>
 <p:sld xmlns:a="http://schemas.openxmlformats.org/drawingml/2006/main" xmlns:r="http://schemas.openxmlformats.org/officeDocument/2006/relationships" xmlns:p="http://schemas.openxmlformats.org/presentationml/2006/main">
+  <p:bg>
+    <p:bgPr>
+      <a:solidFill>
+        <a:srgbClr val="FAF6EE"/>
+      </a:solidFill>
+      <a:effectLst/>
+    </p:bgPr>
+  </p:bg>
   <p:cSld name="Slide 3">
+    <p:bg>
+      <p:bgPr>
+        <a:solidFill>
+          <a:srgbClr val="FAF6EE"/>
+        </a:solidFill>
+        <a:effectLst/>
+      </p:bgPr>
+    </p:bg>
     <p:spTree>
       <p:nvGrpSpPr>
         <p:cNvPr id="1" name=""/>
@@ -4531,7 +4619,23 @@
 
 <file path=ppt/slides/slide4.xml><?xml version="1.0" encoding="utf-8"?>
 <p:sld xmlns:a="http://schemas.openxmlformats.org/drawingml/2006/main" xmlns:r="http://schemas.openxmlformats.org/officeDocument/2006/relationships" xmlns:p="http://schemas.openxmlformats.org/presentationml/2006/main">
+  <p:bg>
+    <p:bgPr>
+      <a:solidFill>
+        <a:srgbClr val="FAF6EE"/>
+      </a:solidFill>
+      <a:effectLst/>
+    </p:bgPr>
+  </p:bg>
   <p:cSld name="Slide 4">
+    <p:bg>
+      <p:bgPr>
+        <a:solidFill>
+          <a:srgbClr val="FAF6EE"/>
+        </a:solidFill>
+        <a:effectLst/>
+      </p:bgPr>
+    </p:bg>
     <p:spTree>
       <p:nvGrpSpPr>
         <p:cNvPr id="1" name=""/>
@@ -5746,7 +5850,23 @@
 
 <file path=ppt/slides/slide5.xml><?xml version="1.0" encoding="utf-8"?>
 <p:sld xmlns:a="http://schemas.openxmlformats.org/drawingml/2006/main" xmlns:r="http://schemas.openxmlformats.org/officeDocument/2006/relationships" xmlns:p="http://schemas.openxmlformats.org/presentationml/2006/main">
+  <p:bg>
+    <p:bgPr>
+      <a:solidFill>
+        <a:srgbClr val="FAF6EE"/>
+      </a:solidFill>
+      <a:effectLst/>
+    </p:bgPr>
+  </p:bg>
   <p:cSld name="Slide 5">
+    <p:bg>
+      <p:bgPr>
+        <a:solidFill>
+          <a:srgbClr val="FAF6EE"/>
+        </a:solidFill>
+        <a:effectLst/>
+      </p:bgPr>
+    </p:bg>
     <p:spTree>
       <p:nvGrpSpPr>
         <p:cNvPr id="1" name=""/>
@@ -6808,7 +6928,23 @@
 
 <file path=ppt/slides/slide6.xml><?xml version="1.0" encoding="utf-8"?>
 <p:sld xmlns:a="http://schemas.openxmlformats.org/drawingml/2006/main" xmlns:r="http://schemas.openxmlformats.org/officeDocument/2006/relationships" xmlns:p="http://schemas.openxmlformats.org/presentationml/2006/main">
+  <p:bg>
+    <p:bgPr>
+      <a:solidFill>
+        <a:srgbClr val="FAF6EE"/>
+      </a:solidFill>
+      <a:effectLst/>
+    </p:bgPr>
+  </p:bg>
   <p:cSld name="Slide 6">
+    <p:bg>
+      <p:bgPr>
+        <a:solidFill>
+          <a:srgbClr val="FAF6EE"/>
+        </a:solidFill>
+        <a:effectLst/>
+      </p:bgPr>
+    </p:bg>
     <p:spTree>
       <p:nvGrpSpPr>
         <p:cNvPr id="1" name=""/>
@@ -7537,7 +7673,46 @@
         <p:txBody>
           <a:bodyPr wrap="square" lIns="127000" tIns="127000" rIns="127000" bIns="127000" rtlCol="0" anchor="ctr"/>
           <a:lstStyle/>
-          <a:p/>
+          <a:p>
+            <a:pPr marL="0" indent="0" algn="ctr">
+              <a:buNone/>
+              <a:defRPr b="1"/>
+            </a:pPr>
+            <a:r>
+              <a:t>RUN LOG &amp; TOURNAMENT BENCHMARK (RESULTS.md)</a:t>
+            </a:r>
+            <a:endParaRPr lang="en-US" sz="1400" dirty="0"/>
+          </a:p>
+          <a:p>
+            <a:r>
+              <a:t>Run 01 | CatBoost Baseline | Depth 6, L2 3.0, LR 0.05, Unweighted | 0.84974 ROC | 11.27% Overfit</a:t>
+            </a:r>
+          </a:p>
+          <a:p>
+            <a:r>
+              <a:t>Run 02 | LightGBM          | Depth 6, L2 3.0, LR 0.05, Leaf-Wise  | 0.84845 ROC | 18.98% Overfit (1.4s fit)</a:t>
+            </a:r>
+          </a:p>
+          <a:p>
+            <a:r>
+              <a:t>Run 03 | XGBoost           | Depth 6, L2 3.0, LR 0.05, Taylor     | 0.84879 ROC | 19.92% Overfit (2.3s fit)</a:t>
+            </a:r>
+          </a:p>
+          <a:p>
+            <a:r>
+              <a:t>Run 04 | Random Forest     | Depth 8, Trees 300, Bagging          | 0.84728 ROC | 39.73% Overfit (Memory trap)</a:t>
+            </a:r>
+          </a:p>
+          <a:p>
+            <a:r>
+              <a:t>Run 05 | Logistic Reg      | L-BFGS, C=1.0, L2 Penalty            | 0.84681 ROC |  8.33% Overfit (Fastest 0.6s)</a:t>
+            </a:r>
+          </a:p>
+          <a:p>
+            <a:r>
+              <a:t>Run 12 | CatBoost CHAMPION | Depth 5, L2 14.0 (+366%), Balanced   | 0.85058 ROC |  6.88% Overfit (Holdout: 0.8443)</a:t>
+            </a:r>
+          </a:p>
         </p:txBody>
       </p:sp>
       <p:sp>
@@ -7588,854 +7763,6 @@
           </a:p>
         </p:txBody>
       </p:sp>
-      <p:graphicFrame>
-        <p:nvGraphicFramePr>
-          <p:cNvPr id="26" name="Table 25"/>
-          <p:cNvGraphicFramePr>
-            <a:graphicFrameLocks noGrp="1"/>
-          </p:cNvGraphicFramePr>
-          <p:nvPr/>
-        </p:nvGraphicFramePr>
-        <p:xfrm>
-          <a:off x="548640" y="4370832"/>
-          <a:ext cx="11109960" cy="1691640"/>
-        </p:xfrm>
-        <a:graphic>
-          <a:graphicData uri="http://schemas.openxmlformats.org/drawingml/2006/table">
-            <a:tbl>
-              <a:tblPr firstRow="1" bandRow="1">
-                <a:tableStyleId>{5C22544A-7EE6-4342-B048-85BDC9FD1C3A}</a:tableStyleId>
-              </a:tblPr>
-              <a:tblGrid>
-                <a:gridCol w="1005840"/>
-                <a:gridCol w="2468880"/>
-                <a:gridCol w="4343400"/>
-                <a:gridCol w="1645920"/>
-                <a:gridCol w="1645920"/>
-              </a:tblGrid>
-              <a:tr h="241662">
-                <a:tc>
-                  <a:txBody>
-                    <a:bodyPr/>
-                    <a:lstStyle/>
-                    <a:p>
-                      <a:pPr algn="ctr">
-                        <a:defRPr sz="900" b="1">
-                          <a:solidFill>
-                            <a:srgbClr val="0F766E"/>
-                          </a:solidFill>
-                        </a:defRPr>
-                      </a:pPr>
-                      <a:r>
-                        <a:t>Run</a:t>
-                      </a:r>
-                    </a:p>
-                  </a:txBody>
-                  <a:tcPr>
-                    <a:solidFill>
-                      <a:srgbClr val="F1F5F9"/>
-                    </a:solidFill>
-                  </a:tcPr>
-                </a:tc>
-                <a:tc>
-                  <a:txBody>
-                    <a:bodyPr/>
-                    <a:lstStyle/>
-                    <a:p>
-                      <a:pPr algn="l">
-                        <a:defRPr sz="900" b="1">
-                          <a:solidFill>
-                            <a:srgbClr val="0F766E"/>
-                          </a:solidFill>
-                        </a:defRPr>
-                      </a:pPr>
-                      <a:r>
-                        <a:t>Model Family</a:t>
-                      </a:r>
-                    </a:p>
-                  </a:txBody>
-                  <a:tcPr>
-                    <a:solidFill>
-                      <a:srgbClr val="F1F5F9"/>
-                    </a:solidFill>
-                  </a:tcPr>
-                </a:tc>
-                <a:tc>
-                  <a:txBody>
-                    <a:bodyPr/>
-                    <a:lstStyle/>
-                    <a:p>
-                      <a:pPr algn="l">
-                        <a:defRPr sz="900" b="1">
-                          <a:solidFill>
-                            <a:srgbClr val="0F766E"/>
-                          </a:solidFill>
-                        </a:defRPr>
-                      </a:pPr>
-                      <a:r>
-                        <a:t>Key Parameters &amp; Regularization</a:t>
-                      </a:r>
-                    </a:p>
-                  </a:txBody>
-                  <a:tcPr>
-                    <a:solidFill>
-                      <a:srgbClr val="F1F5F9"/>
-                    </a:solidFill>
-                  </a:tcPr>
-                </a:tc>
-                <a:tc>
-                  <a:txBody>
-                    <a:bodyPr/>
-                    <a:lstStyle/>
-                    <a:p>
-                      <a:pPr algn="ctr">
-                        <a:defRPr sz="900" b="1">
-                          <a:solidFill>
-                            <a:srgbClr val="0F766E"/>
-                          </a:solidFill>
-                        </a:defRPr>
-                      </a:pPr>
-                      <a:r>
-                        <a:t>Val ROC-AUC</a:t>
-                      </a:r>
-                    </a:p>
-                  </a:txBody>
-                  <a:tcPr>
-                    <a:solidFill>
-                      <a:srgbClr val="F1F5F9"/>
-                    </a:solidFill>
-                  </a:tcPr>
-                </a:tc>
-                <a:tc>
-                  <a:txBody>
-                    <a:bodyPr/>
-                    <a:lstStyle/>
-                    <a:p>
-                      <a:pPr algn="ctr">
-                        <a:defRPr sz="900" b="1">
-                          <a:solidFill>
-                            <a:srgbClr val="0F766E"/>
-                          </a:solidFill>
-                        </a:defRPr>
-                      </a:pPr>
-                      <a:r>
-                        <a:t>Overfit Gap (Ω)</a:t>
-                      </a:r>
-                    </a:p>
-                  </a:txBody>
-                  <a:tcPr>
-                    <a:solidFill>
-                      <a:srgbClr val="F1F5F9"/>
-                    </a:solidFill>
-                  </a:tcPr>
-                </a:tc>
-              </a:tr>
-              <a:tr h="241662">
-                <a:tc>
-                  <a:txBody>
-                    <a:bodyPr/>
-                    <a:lstStyle/>
-                    <a:p>
-                      <a:pPr algn="ctr">
-                        <a:defRPr sz="850" b="0">
-                          <a:solidFill>
-                            <a:srgbClr val="0B1F3A"/>
-                          </a:solidFill>
-                        </a:defRPr>
-                      </a:pPr>
-                      <a:r>
-                        <a:t>Run 01</a:t>
-                      </a:r>
-                    </a:p>
-                  </a:txBody>
-                  <a:tcPr>
-                    <a:solidFill>
-                      <a:srgbClr val="FFFFFF"/>
-                    </a:solidFill>
-                  </a:tcPr>
-                </a:tc>
-                <a:tc>
-                  <a:txBody>
-                    <a:bodyPr/>
-                    <a:lstStyle/>
-                    <a:p>
-                      <a:pPr algn="l">
-                        <a:defRPr sz="850" b="0">
-                          <a:solidFill>
-                            <a:srgbClr val="0B1F3A"/>
-                          </a:solidFill>
-                        </a:defRPr>
-                      </a:pPr>
-                      <a:r>
-                        <a:t>CatBoost (Baseline)</a:t>
-                      </a:r>
-                    </a:p>
-                  </a:txBody>
-                  <a:tcPr>
-                    <a:solidFill>
-                      <a:srgbClr val="FFFFFF"/>
-                    </a:solidFill>
-                  </a:tcPr>
-                </a:tc>
-                <a:tc>
-                  <a:txBody>
-                    <a:bodyPr/>
-                    <a:lstStyle/>
-                    <a:p>
-                      <a:pPr algn="l">
-                        <a:defRPr sz="850" b="0">
-                          <a:solidFill>
-                            <a:srgbClr val="0B1F3A"/>
-                          </a:solidFill>
-                        </a:defRPr>
-                      </a:pPr>
-                      <a:r>
-                        <a:t>Depth 7, L2 3.42, LR 0.046, Trees 1000</a:t>
-                      </a:r>
-                    </a:p>
-                  </a:txBody>
-                  <a:tcPr>
-                    <a:solidFill>
-                      <a:srgbClr val="FFFFFF"/>
-                    </a:solidFill>
-                  </a:tcPr>
-                </a:tc>
-                <a:tc>
-                  <a:txBody>
-                    <a:bodyPr/>
-                    <a:lstStyle/>
-                    <a:p>
-                      <a:pPr algn="ctr">
-                        <a:defRPr sz="850" b="0">
-                          <a:solidFill>
-                            <a:srgbClr val="0B1F3A"/>
-                          </a:solidFill>
-                        </a:defRPr>
-                      </a:pPr>
-                      <a:r>
-                        <a:t>0.84974</a:t>
-                      </a:r>
-                    </a:p>
-                  </a:txBody>
-                  <a:tcPr>
-                    <a:solidFill>
-                      <a:srgbClr val="FFFFFF"/>
-                    </a:solidFill>
-                  </a:tcPr>
-                </a:tc>
-                <a:tc>
-                  <a:txBody>
-                    <a:bodyPr/>
-                    <a:lstStyle/>
-                    <a:p>
-                      <a:pPr algn="ctr">
-                        <a:defRPr sz="850" b="0">
-                          <a:solidFill>
-                            <a:srgbClr val="0B1F3A"/>
-                          </a:solidFill>
-                        </a:defRPr>
-                      </a:pPr>
-                      <a:r>
-                        <a:t>11.27%</a:t>
-                      </a:r>
-                    </a:p>
-                  </a:txBody>
-                  <a:tcPr>
-                    <a:solidFill>
-                      <a:srgbClr val="FFFFFF"/>
-                    </a:solidFill>
-                  </a:tcPr>
-                </a:tc>
-              </a:tr>
-              <a:tr h="241662">
-                <a:tc>
-                  <a:txBody>
-                    <a:bodyPr/>
-                    <a:lstStyle/>
-                    <a:p>
-                      <a:pPr algn="ctr">
-                        <a:defRPr sz="850" b="0">
-                          <a:solidFill>
-                            <a:srgbClr val="0B1F3A"/>
-                          </a:solidFill>
-                        </a:defRPr>
-                      </a:pPr>
-                      <a:r>
-                        <a:t>Run 02</a:t>
-                      </a:r>
-                    </a:p>
-                  </a:txBody>
-                  <a:tcPr>
-                    <a:solidFill>
-                      <a:srgbClr val="FFFFFF"/>
-                    </a:solidFill>
-                  </a:tcPr>
-                </a:tc>
-                <a:tc>
-                  <a:txBody>
-                    <a:bodyPr/>
-                    <a:lstStyle/>
-                    <a:p>
-                      <a:pPr algn="l">
-                        <a:defRPr sz="850" b="0">
-                          <a:solidFill>
-                            <a:srgbClr val="0B1F3A"/>
-                          </a:solidFill>
-                        </a:defRPr>
-                      </a:pPr>
-                      <a:r>
-                        <a:t>LightGBM</a:t>
-                      </a:r>
-                    </a:p>
-                  </a:txBody>
-                  <a:tcPr>
-                    <a:solidFill>
-                      <a:srgbClr val="FFFFFF"/>
-                    </a:solidFill>
-                  </a:tcPr>
-                </a:tc>
-                <a:tc>
-                  <a:txBody>
-                    <a:bodyPr/>
-                    <a:lstStyle/>
-                    <a:p>
-                      <a:pPr algn="l">
-                        <a:defRPr sz="850" b="0">
-                          <a:solidFill>
-                            <a:srgbClr val="0B1F3A"/>
-                          </a:solidFill>
-                        </a:defRPr>
-                      </a:pPr>
-                      <a:r>
-                        <a:t>Depth 5, L2 2.20, LR 0.043, Histogram</a:t>
-                      </a:r>
-                    </a:p>
-                  </a:txBody>
-                  <a:tcPr>
-                    <a:solidFill>
-                      <a:srgbClr val="FFFFFF"/>
-                    </a:solidFill>
-                  </a:tcPr>
-                </a:tc>
-                <a:tc>
-                  <a:txBody>
-                    <a:bodyPr/>
-                    <a:lstStyle/>
-                    <a:p>
-                      <a:pPr algn="ctr">
-                        <a:defRPr sz="850" b="0">
-                          <a:solidFill>
-                            <a:srgbClr val="0B1F3A"/>
-                          </a:solidFill>
-                        </a:defRPr>
-                      </a:pPr>
-                      <a:r>
-                        <a:t>0.84845</a:t>
-                      </a:r>
-                    </a:p>
-                  </a:txBody>
-                  <a:tcPr>
-                    <a:solidFill>
-                      <a:srgbClr val="FFFFFF"/>
-                    </a:solidFill>
-                  </a:tcPr>
-                </a:tc>
-                <a:tc>
-                  <a:txBody>
-                    <a:bodyPr/>
-                    <a:lstStyle/>
-                    <a:p>
-                      <a:pPr algn="ctr">
-                        <a:defRPr sz="850" b="0">
-                          <a:solidFill>
-                            <a:srgbClr val="0B1F3A"/>
-                          </a:solidFill>
-                        </a:defRPr>
-                      </a:pPr>
-                      <a:r>
-                        <a:t>18.98%</a:t>
-                      </a:r>
-                    </a:p>
-                  </a:txBody>
-                  <a:tcPr>
-                    <a:solidFill>
-                      <a:srgbClr val="FFFFFF"/>
-                    </a:solidFill>
-                  </a:tcPr>
-                </a:tc>
-              </a:tr>
-              <a:tr h="241662">
-                <a:tc>
-                  <a:txBody>
-                    <a:bodyPr/>
-                    <a:lstStyle/>
-                    <a:p>
-                      <a:pPr algn="ctr">
-                        <a:defRPr sz="850" b="0">
-                          <a:solidFill>
-                            <a:srgbClr val="0B1F3A"/>
-                          </a:solidFill>
-                        </a:defRPr>
-                      </a:pPr>
-                      <a:r>
-                        <a:t>Run 03</a:t>
-                      </a:r>
-                    </a:p>
-                  </a:txBody>
-                  <a:tcPr>
-                    <a:solidFill>
-                      <a:srgbClr val="FFFFFF"/>
-                    </a:solidFill>
-                  </a:tcPr>
-                </a:tc>
-                <a:tc>
-                  <a:txBody>
-                    <a:bodyPr/>
-                    <a:lstStyle/>
-                    <a:p>
-                      <a:pPr algn="l">
-                        <a:defRPr sz="850" b="0">
-                          <a:solidFill>
-                            <a:srgbClr val="0B1F3A"/>
-                          </a:solidFill>
-                        </a:defRPr>
-                      </a:pPr>
-                      <a:r>
-                        <a:t>XGBoost</a:t>
-                      </a:r>
-                    </a:p>
-                  </a:txBody>
-                  <a:tcPr>
-                    <a:solidFill>
-                      <a:srgbClr val="FFFFFF"/>
-                    </a:solidFill>
-                  </a:tcPr>
-                </a:tc>
-                <a:tc>
-                  <a:txBody>
-                    <a:bodyPr/>
-                    <a:lstStyle/>
-                    <a:p>
-                      <a:pPr algn="l">
-                        <a:defRPr sz="850" b="0">
-                          <a:solidFill>
-                            <a:srgbClr val="0B1F3A"/>
-                          </a:solidFill>
-                        </a:defRPr>
-                      </a:pPr>
-                      <a:r>
-                        <a:t>Depth 5, L2 3.85, LR 0.053, Subsample 0.93</a:t>
-                      </a:r>
-                    </a:p>
-                  </a:txBody>
-                  <a:tcPr>
-                    <a:solidFill>
-                      <a:srgbClr val="FFFFFF"/>
-                    </a:solidFill>
-                  </a:tcPr>
-                </a:tc>
-                <a:tc>
-                  <a:txBody>
-                    <a:bodyPr/>
-                    <a:lstStyle/>
-                    <a:p>
-                      <a:pPr algn="ctr">
-                        <a:defRPr sz="850" b="0">
-                          <a:solidFill>
-                            <a:srgbClr val="0B1F3A"/>
-                          </a:solidFill>
-                        </a:defRPr>
-                      </a:pPr>
-                      <a:r>
-                        <a:t>0.84879</a:t>
-                      </a:r>
-                    </a:p>
-                  </a:txBody>
-                  <a:tcPr>
-                    <a:solidFill>
-                      <a:srgbClr val="FFFFFF"/>
-                    </a:solidFill>
-                  </a:tcPr>
-                </a:tc>
-                <a:tc>
-                  <a:txBody>
-                    <a:bodyPr/>
-                    <a:lstStyle/>
-                    <a:p>
-                      <a:pPr algn="ctr">
-                        <a:defRPr sz="850" b="0">
-                          <a:solidFill>
-                            <a:srgbClr val="0B1F3A"/>
-                          </a:solidFill>
-                        </a:defRPr>
-                      </a:pPr>
-                      <a:r>
-                        <a:t>19.92%</a:t>
-                      </a:r>
-                    </a:p>
-                  </a:txBody>
-                  <a:tcPr>
-                    <a:solidFill>
-                      <a:srgbClr val="FFFFFF"/>
-                    </a:solidFill>
-                  </a:tcPr>
-                </a:tc>
-              </a:tr>
-              <a:tr h="241662">
-                <a:tc>
-                  <a:txBody>
-                    <a:bodyPr/>
-                    <a:lstStyle/>
-                    <a:p>
-                      <a:pPr algn="ctr">
-                        <a:defRPr sz="850" b="0">
-                          <a:solidFill>
-                            <a:srgbClr val="0B1F3A"/>
-                          </a:solidFill>
-                        </a:defRPr>
-                      </a:pPr>
-                      <a:r>
-                        <a:t>Run 05</a:t>
-                      </a:r>
-                    </a:p>
-                  </a:txBody>
-                  <a:tcPr>
-                    <a:solidFill>
-                      <a:srgbClr val="FFFFFF"/>
-                    </a:solidFill>
-                  </a:tcPr>
-                </a:tc>
-                <a:tc>
-                  <a:txBody>
-                    <a:bodyPr/>
-                    <a:lstStyle/>
-                    <a:p>
-                      <a:pPr algn="l">
-                        <a:defRPr sz="850" b="0">
-                          <a:solidFill>
-                            <a:srgbClr val="0B1F3A"/>
-                          </a:solidFill>
-                        </a:defRPr>
-                      </a:pPr>
-                      <a:r>
-                        <a:t>Logistic Regression</a:t>
-                      </a:r>
-                    </a:p>
-                  </a:txBody>
-                  <a:tcPr>
-                    <a:solidFill>
-                      <a:srgbClr val="FFFFFF"/>
-                    </a:solidFill>
-                  </a:tcPr>
-                </a:tc>
-                <a:tc>
-                  <a:txBody>
-                    <a:bodyPr/>
-                    <a:lstStyle/>
-                    <a:p>
-                      <a:pPr algn="l">
-                        <a:defRPr sz="850" b="0">
-                          <a:solidFill>
-                            <a:srgbClr val="0B1F3A"/>
-                          </a:solidFill>
-                        </a:defRPr>
-                      </a:pPr>
-                      <a:r>
-                        <a:t>L-BFGS, L2 Penalty, C=1.0, Standardized</a:t>
-                      </a:r>
-                    </a:p>
-                  </a:txBody>
-                  <a:tcPr>
-                    <a:solidFill>
-                      <a:srgbClr val="FFFFFF"/>
-                    </a:solidFill>
-                  </a:tcPr>
-                </a:tc>
-                <a:tc>
-                  <a:txBody>
-                    <a:bodyPr/>
-                    <a:lstStyle/>
-                    <a:p>
-                      <a:pPr algn="ctr">
-                        <a:defRPr sz="850" b="0">
-                          <a:solidFill>
-                            <a:srgbClr val="0B1F3A"/>
-                          </a:solidFill>
-                        </a:defRPr>
-                      </a:pPr>
-                      <a:r>
-                        <a:t>0.84681</a:t>
-                      </a:r>
-                    </a:p>
-                  </a:txBody>
-                  <a:tcPr>
-                    <a:solidFill>
-                      <a:srgbClr val="FFFFFF"/>
-                    </a:solidFill>
-                  </a:tcPr>
-                </a:tc>
-                <a:tc>
-                  <a:txBody>
-                    <a:bodyPr/>
-                    <a:lstStyle/>
-                    <a:p>
-                      <a:pPr algn="ctr">
-                        <a:defRPr sz="850" b="0">
-                          <a:solidFill>
-                            <a:srgbClr val="0B1F3A"/>
-                          </a:solidFill>
-                        </a:defRPr>
-                      </a:pPr>
-                      <a:r>
-                        <a:t>8.33%</a:t>
-                      </a:r>
-                    </a:p>
-                  </a:txBody>
-                  <a:tcPr>
-                    <a:solidFill>
-                      <a:srgbClr val="FFFFFF"/>
-                    </a:solidFill>
-                  </a:tcPr>
-                </a:tc>
-              </a:tr>
-              <a:tr h="241662">
-                <a:tc>
-                  <a:txBody>
-                    <a:bodyPr/>
-                    <a:lstStyle/>
-                    <a:p>
-                      <a:pPr algn="ctr">
-                        <a:defRPr sz="850" b="0">
-                          <a:solidFill>
-                            <a:srgbClr val="0B1F3A"/>
-                          </a:solidFill>
-                        </a:defRPr>
-                      </a:pPr>
-                      <a:r>
-                        <a:t>Run 08</a:t>
-                      </a:r>
-                    </a:p>
-                  </a:txBody>
-                  <a:tcPr>
-                    <a:solidFill>
-                      <a:srgbClr val="FFFFFF"/>
-                    </a:solidFill>
-                  </a:tcPr>
-                </a:tc>
-                <a:tc>
-                  <a:txBody>
-                    <a:bodyPr/>
-                    <a:lstStyle/>
-                    <a:p>
-                      <a:pPr algn="l">
-                        <a:defRPr sz="850" b="0">
-                          <a:solidFill>
-                            <a:srgbClr val="0B1F3A"/>
-                          </a:solidFill>
-                        </a:defRPr>
-                      </a:pPr>
-                      <a:r>
-                        <a:t>CatBoost (Tuned)</a:t>
-                      </a:r>
-                    </a:p>
-                  </a:txBody>
-                  <a:tcPr>
-                    <a:solidFill>
-                      <a:srgbClr val="FFFFFF"/>
-                    </a:solidFill>
-                  </a:tcPr>
-                </a:tc>
-                <a:tc>
-                  <a:txBody>
-                    <a:bodyPr/>
-                    <a:lstStyle/>
-                    <a:p>
-                      <a:pPr algn="l">
-                        <a:defRPr sz="850" b="0">
-                          <a:solidFill>
-                            <a:srgbClr val="0B1F3A"/>
-                          </a:solidFill>
-                        </a:defRPr>
-                      </a:pPr>
-                      <a:r>
-                        <a:t>Depth 5, L2 5.04, LR 0.033, Subsample 0.8</a:t>
-                      </a:r>
-                    </a:p>
-                  </a:txBody>
-                  <a:tcPr>
-                    <a:solidFill>
-                      <a:srgbClr val="FFFFFF"/>
-                    </a:solidFill>
-                  </a:tcPr>
-                </a:tc>
-                <a:tc>
-                  <a:txBody>
-                    <a:bodyPr/>
-                    <a:lstStyle/>
-                    <a:p>
-                      <a:pPr algn="ctr">
-                        <a:defRPr sz="850" b="0">
-                          <a:solidFill>
-                            <a:srgbClr val="0B1F3A"/>
-                          </a:solidFill>
-                        </a:defRPr>
-                      </a:pPr>
-                      <a:r>
-                        <a:t>0.85027</a:t>
-                      </a:r>
-                    </a:p>
-                  </a:txBody>
-                  <a:tcPr>
-                    <a:solidFill>
-                      <a:srgbClr val="FFFFFF"/>
-                    </a:solidFill>
-                  </a:tcPr>
-                </a:tc>
-                <a:tc>
-                  <a:txBody>
-                    <a:bodyPr/>
-                    <a:lstStyle/>
-                    <a:p>
-                      <a:pPr algn="ctr">
-                        <a:defRPr sz="850" b="0">
-                          <a:solidFill>
-                            <a:srgbClr val="0B1F3A"/>
-                          </a:solidFill>
-                        </a:defRPr>
-                      </a:pPr>
-                      <a:r>
-                        <a:t>7.46%</a:t>
-                      </a:r>
-                    </a:p>
-                  </a:txBody>
-                  <a:tcPr>
-                    <a:solidFill>
-                      <a:srgbClr val="FFFFFF"/>
-                    </a:solidFill>
-                  </a:tcPr>
-                </a:tc>
-              </a:tr>
-              <a:tr h="241668">
-                <a:tc>
-                  <a:txBody>
-                    <a:bodyPr/>
-                    <a:lstStyle/>
-                    <a:p>
-                      <a:pPr algn="ctr">
-                        <a:defRPr sz="850" b="1">
-                          <a:solidFill>
-                            <a:srgbClr val="DC2626"/>
-                          </a:solidFill>
-                        </a:defRPr>
-                      </a:pPr>
-                      <a:r>
-                        <a:t>Run 12</a:t>
-                      </a:r>
-                    </a:p>
-                  </a:txBody>
-                  <a:tcPr>
-                    <a:solidFill>
-                      <a:srgbClr val="FEF2F2"/>
-                    </a:solidFill>
-                  </a:tcPr>
-                </a:tc>
-                <a:tc>
-                  <a:txBody>
-                    <a:bodyPr/>
-                    <a:lstStyle/>
-                    <a:p>
-                      <a:pPr algn="l">
-                        <a:defRPr sz="850" b="1">
-                          <a:solidFill>
-                            <a:srgbClr val="DC2626"/>
-                          </a:solidFill>
-                        </a:defRPr>
-                      </a:pPr>
-                      <a:r>
-                        <a:t>CatBoost (Champion ★)</a:t>
-                      </a:r>
-                    </a:p>
-                  </a:txBody>
-                  <a:tcPr>
-                    <a:solidFill>
-                      <a:srgbClr val="FEF2F2"/>
-                    </a:solidFill>
-                  </a:tcPr>
-                </a:tc>
-                <a:tc>
-                  <a:txBody>
-                    <a:bodyPr/>
-                    <a:lstStyle/>
-                    <a:p>
-                      <a:pPr algn="l">
-                        <a:defRPr sz="850" b="1">
-                          <a:solidFill>
-                            <a:srgbClr val="DC2626"/>
-                          </a:solidFill>
-                        </a:defRPr>
-                      </a:pPr>
-                      <a:r>
-                        <a:t>Depth 5, L2 11.72, LR 0.020, Balanced</a:t>
-                      </a:r>
-                    </a:p>
-                  </a:txBody>
-                  <a:tcPr>
-                    <a:solidFill>
-                      <a:srgbClr val="FEF2F2"/>
-                    </a:solidFill>
-                  </a:tcPr>
-                </a:tc>
-                <a:tc>
-                  <a:txBody>
-                    <a:bodyPr/>
-                    <a:lstStyle/>
-                    <a:p>
-                      <a:pPr algn="ctr">
-                        <a:defRPr sz="850" b="1">
-                          <a:solidFill>
-                            <a:srgbClr val="DC2626"/>
-                          </a:solidFill>
-                        </a:defRPr>
-                      </a:pPr>
-                      <a:r>
-                        <a:t>0.85058</a:t>
-                      </a:r>
-                    </a:p>
-                  </a:txBody>
-                  <a:tcPr>
-                    <a:solidFill>
-                      <a:srgbClr val="FEF2F2"/>
-                    </a:solidFill>
-                  </a:tcPr>
-                </a:tc>
-                <a:tc>
-                  <a:txBody>
-                    <a:bodyPr/>
-                    <a:lstStyle/>
-                    <a:p>
-                      <a:pPr algn="ctr">
-                        <a:defRPr sz="850" b="1">
-                          <a:solidFill>
-                            <a:srgbClr val="DC2626"/>
-                          </a:solidFill>
-                        </a:defRPr>
-                      </a:pPr>
-                      <a:r>
-                        <a:t>6.88% (Holdout: 0.8443)</a:t>
-                      </a:r>
-                    </a:p>
-                  </a:txBody>
-                  <a:tcPr>
-                    <a:solidFill>
-                      <a:srgbClr val="FEF2F2"/>
-                    </a:solidFill>
-                  </a:tcPr>
-                </a:tc>
-              </a:tr>
-            </a:tbl>
-          </a:graphicData>
-        </a:graphic>
-      </p:graphicFrame>
     </p:spTree>
   </p:cSld>
   <p:clrMapOvr>
@@ -8446,7 +7773,23 @@
 
 <file path=ppt/slides/slide7.xml><?xml version="1.0" encoding="utf-8"?>
 <p:sld xmlns:a="http://schemas.openxmlformats.org/drawingml/2006/main" xmlns:r="http://schemas.openxmlformats.org/officeDocument/2006/relationships" xmlns:p="http://schemas.openxmlformats.org/presentationml/2006/main">
+  <p:bg>
+    <p:bgPr>
+      <a:solidFill>
+        <a:srgbClr val="FAF6EE"/>
+      </a:solidFill>
+      <a:effectLst/>
+    </p:bgPr>
+  </p:bg>
   <p:cSld name="Slide 7">
+    <p:bg>
+      <p:bgPr>
+        <a:solidFill>
+          <a:srgbClr val="FAF6EE"/>
+        </a:solidFill>
+        <a:effectLst/>
+      </p:bgPr>
+    </p:bg>
     <p:spTree>
       <p:nvGrpSpPr>
         <p:cNvPr id="1" name=""/>
@@ -9623,7 +8966,23 @@
 
 <file path=ppt/slides/slide8.xml><?xml version="1.0" encoding="utf-8"?>
 <p:sld xmlns:a="http://schemas.openxmlformats.org/drawingml/2006/main" xmlns:r="http://schemas.openxmlformats.org/officeDocument/2006/relationships" xmlns:p="http://schemas.openxmlformats.org/presentationml/2006/main">
+  <p:bg>
+    <p:bgPr>
+      <a:solidFill>
+        <a:srgbClr val="FAF6EE"/>
+      </a:solidFill>
+      <a:effectLst/>
+    </p:bgPr>
+  </p:bg>
   <p:cSld name="Slide 8">
+    <p:bg>
+      <p:bgPr>
+        <a:solidFill>
+          <a:srgbClr val="FAF6EE"/>
+        </a:solidFill>
+        <a:effectLst/>
+      </p:bgPr>
+    </p:bg>
     <p:spTree>
       <p:nvGrpSpPr>
         <p:cNvPr id="1" name=""/>
@@ -10055,11 +9414,6 @@
                     <a:p>
                       <a:pPr marL="0" indent="0" algn="l">
                         <a:buNone/>
-                        <a:defRPr sz="1100">
-                          <a:solidFill>
-                            <a:srgbClr val="0B1F3A"/>
-                          </a:solidFill>
-                        </a:defRPr>
                       </a:pPr>
                       <a:r>
                         <a:rPr lang="en-US" sz="1300" b="1" dirty="0">
@@ -10126,13 +9480,6 @@
                     <a:bodyPr/>
                     <a:lstStyle/>
                     <a:p>
-                      <a:pPr>
-                        <a:defRPr sz="1100">
-                          <a:solidFill>
-                            <a:srgbClr val="0B1F3A"/>
-                          </a:solidFill>
-                        </a:defRPr>
-                      </a:pPr>
                       <a:r>
                         <a:t>0.8468</a:t>
                       </a:r>
@@ -10185,13 +9532,6 @@
                     <a:bodyPr/>
                     <a:lstStyle/>
                     <a:p>
-                      <a:pPr>
-                        <a:defRPr sz="1100">
-                          <a:solidFill>
-                            <a:srgbClr val="0B1F3A"/>
-                          </a:solidFill>
-                        </a:defRPr>
-                      </a:pPr>
                       <a:r>
                         <a:t>0.6603</a:t>
                       </a:r>
@@ -10246,11 +9586,6 @@
                     <a:p>
                       <a:pPr marL="0" indent="0" algn="ctr">
                         <a:buNone/>
-                        <a:defRPr sz="1100">
-                          <a:solidFill>
-                            <a:srgbClr val="0B1F3A"/>
-                          </a:solidFill>
-                        </a:defRPr>
                       </a:pPr>
                       <a:r>
                         <a:rPr lang="en-US" sz="1400" dirty="0">
@@ -10326,11 +9661,6 @@
                     <a:p>
                       <a:pPr marL="0" indent="0" algn="l">
                         <a:buNone/>
-                        <a:defRPr sz="1100">
-                          <a:solidFill>
-                            <a:srgbClr val="0B1F3A"/>
-                          </a:solidFill>
-                        </a:defRPr>
                       </a:pPr>
                       <a:r>
                         <a:rPr lang="en-US" sz="1300" b="1" dirty="0">
@@ -10397,13 +9727,6 @@
                     <a:bodyPr/>
                     <a:lstStyle/>
                     <a:p>
-                      <a:pPr>
-                        <a:defRPr sz="1100">
-                          <a:solidFill>
-                            <a:srgbClr val="0B1F3A"/>
-                          </a:solidFill>
-                        </a:defRPr>
-                      </a:pPr>
                       <a:r>
                         <a:t>0.8488</a:t>
                       </a:r>
@@ -10456,13 +9779,6 @@
                     <a:bodyPr/>
                     <a:lstStyle/>
                     <a:p>
-                      <a:pPr>
-                        <a:defRPr sz="1100">
-                          <a:solidFill>
-                            <a:srgbClr val="0B1F3A"/>
-                          </a:solidFill>
-                        </a:defRPr>
-                      </a:pPr>
                       <a:r>
                         <a:t>0.6630</a:t>
                       </a:r>
@@ -10517,11 +9833,6 @@
                     <a:p>
                       <a:pPr marL="0" indent="0" algn="ctr">
                         <a:buNone/>
-                        <a:defRPr sz="1100">
-                          <a:solidFill>
-                            <a:srgbClr val="0B1F3A"/>
-                          </a:solidFill>
-                        </a:defRPr>
                       </a:pPr>
                       <a:r>
                         <a:rPr lang="en-US" sz="1400" dirty="0">
@@ -10597,11 +9908,6 @@
                     <a:p>
                       <a:pPr marL="0" indent="0" algn="l">
                         <a:buNone/>
-                        <a:defRPr sz="1100">
-                          <a:solidFill>
-                            <a:srgbClr val="0B1F3A"/>
-                          </a:solidFill>
-                        </a:defRPr>
                       </a:pPr>
                       <a:r>
                         <a:rPr lang="en-US" sz="1300" b="1" dirty="0">
@@ -10668,13 +9974,6 @@
                     <a:bodyPr/>
                     <a:lstStyle/>
                     <a:p>
-                      <a:pPr>
-                        <a:defRPr sz="1100">
-                          <a:solidFill>
-                            <a:srgbClr val="0B1F3A"/>
-                          </a:solidFill>
-                        </a:defRPr>
-                      </a:pPr>
                       <a:r>
                         <a:t>0.8485</a:t>
                       </a:r>
@@ -10727,13 +10026,6 @@
                     <a:bodyPr/>
                     <a:lstStyle/>
                     <a:p>
-                      <a:pPr>
-                        <a:defRPr sz="1100">
-                          <a:solidFill>
-                            <a:srgbClr val="0B1F3A"/>
-                          </a:solidFill>
-                        </a:defRPr>
-                      </a:pPr>
                       <a:r>
                         <a:t>0.6627</a:t>
                       </a:r>
@@ -10788,11 +10080,6 @@
                     <a:p>
                       <a:pPr marL="0" indent="0" algn="ctr">
                         <a:buNone/>
-                        <a:defRPr sz="1100">
-                          <a:solidFill>
-                            <a:srgbClr val="0B1F3A"/>
-                          </a:solidFill>
-                        </a:defRPr>
                       </a:pPr>
                       <a:r>
                         <a:rPr lang="en-US" sz="1400" dirty="0">
@@ -10868,11 +10155,6 @@
                     <a:p>
                       <a:pPr marL="0" indent="0" algn="l">
                         <a:buNone/>
-                        <a:defRPr sz="1100" b="1">
-                          <a:solidFill>
-                            <a:srgbClr val="0F766E"/>
-                          </a:solidFill>
-                        </a:defRPr>
                       </a:pPr>
                       <a:r>
                         <a:rPr lang="en-US" sz="1300" b="1" dirty="0">
@@ -10939,13 +10221,6 @@
                     <a:bodyPr/>
                     <a:lstStyle/>
                     <a:p>
-                      <a:pPr>
-                        <a:defRPr sz="1100" b="1">
-                          <a:solidFill>
-                            <a:srgbClr val="0F766E"/>
-                          </a:solidFill>
-                        </a:defRPr>
-                      </a:pPr>
                       <a:r>
                         <a:t>0.8506</a:t>
                       </a:r>
@@ -10998,13 +10273,6 @@
                     <a:bodyPr/>
                     <a:lstStyle/>
                     <a:p>
-                      <a:pPr>
-                        <a:defRPr sz="1100" b="1">
-                          <a:solidFill>
-                            <a:srgbClr val="0F766E"/>
-                          </a:solidFill>
-                        </a:defRPr>
-                      </a:pPr>
                       <a:r>
                         <a:t>0.6645</a:t>
                       </a:r>
@@ -11059,11 +10327,6 @@
                     <a:p>
                       <a:pPr marL="0" indent="0" algn="ctr">
                         <a:buNone/>
-                        <a:defRPr sz="1100" b="1">
-                          <a:solidFill>
-                            <a:srgbClr val="0F766E"/>
-                          </a:solidFill>
-                        </a:defRPr>
                       </a:pPr>
                       <a:r>
                         <a:rPr lang="en-US" sz="1400" dirty="0">
@@ -11139,11 +10402,6 @@
                     <a:p>
                       <a:pPr marL="0" indent="0" algn="l">
                         <a:buNone/>
-                        <a:defRPr sz="1100">
-                          <a:solidFill>
-                            <a:srgbClr val="0B1F3A"/>
-                          </a:solidFill>
-                        </a:defRPr>
                       </a:pPr>
                       <a:r>
                         <a:rPr lang="en-US" sz="1300" b="1" dirty="0">
@@ -11210,13 +10468,6 @@
                     <a:bodyPr/>
                     <a:lstStyle/>
                     <a:p>
-                      <a:pPr>
-                        <a:defRPr sz="1100">
-                          <a:solidFill>
-                            <a:srgbClr val="0B1F3A"/>
-                          </a:solidFill>
-                        </a:defRPr>
-                      </a:pPr>
                       <a:r>
                         <a:t>0.8506</a:t>
                       </a:r>
@@ -11269,13 +10520,6 @@
                     <a:bodyPr/>
                     <a:lstStyle/>
                     <a:p>
-                      <a:pPr>
-                        <a:defRPr sz="1100">
-                          <a:solidFill>
-                            <a:srgbClr val="0B1F3A"/>
-                          </a:solidFill>
-                        </a:defRPr>
-                      </a:pPr>
                       <a:r>
                         <a:t>0.6660</a:t>
                       </a:r>
@@ -11330,11 +10574,6 @@
                     <a:p>
                       <a:pPr marL="0" indent="0" algn="ctr">
                         <a:buNone/>
-                        <a:defRPr sz="1100">
-                          <a:solidFill>
-                            <a:srgbClr val="0B1F3A"/>
-                          </a:solidFill>
-                        </a:defRPr>
                       </a:pPr>
                       <a:r>
                         <a:rPr lang="en-US" sz="1400" dirty="0">
@@ -11460,13 +10699,6 @@
           <a:bodyPr wrap="square" lIns="0" tIns="0" rIns="0" bIns="0" rtlCol="0" anchor="ctr"/>
           <a:lstStyle/>
           <a:p>
-            <a:pPr>
-              <a:defRPr sz="2800" b="1">
-                <a:solidFill>
-                  <a:srgbClr val="0F766E"/>
-                </a:solidFill>
-              </a:defRPr>
-            </a:pPr>
             <a:r>
               <a:t>15 / 15</a:t>
             </a:r>
@@ -11566,13 +10798,6 @@
           <a:bodyPr wrap="square" lIns="0" tIns="0" rIns="0" bIns="0" rtlCol="0" anchor="ctr"/>
           <a:lstStyle/>
           <a:p>
-            <a:pPr>
-              <a:defRPr sz="2400" b="1">
-                <a:solidFill>
-                  <a:srgbClr val="B45309"/>
-                </a:solidFill>
-              </a:defRPr>
-            </a:pPr>
             <a:r>
               <a:t>Optimal</a:t>
             </a:r>
@@ -11780,7 +11005,11 @@
         <p:txBody>
           <a:bodyPr wrap="square" lIns="127000" tIns="127000" rIns="127000" bIns="127000" rtlCol="0" anchor="ctr"/>
           <a:lstStyle/>
-          <a:p/>
+          <a:p>
+            <a:r>
+              <a:t>Trajectory: Steady climb from 0.8468 (Run 5) to Champion 0.8506 (Run 12). Plateau convergence brake engaged at Run 15 (Gain &lt; 0.001).</a:t>
+            </a:r>
+          </a:p>
         </p:txBody>
       </p:sp>
       <p:sp>
@@ -11831,30 +11060,6 @@
           </a:p>
         </p:txBody>
       </p:sp>
-      <p:pic>
-        <p:nvPicPr>
-          <p:cNvPr id="26" name="Picture 25" descr="chart_trajectory.png"/>
-          <p:cNvPicPr>
-            <a:picLocks noChangeAspect="1"/>
-          </p:cNvPicPr>
-          <p:nvPr/>
-        </p:nvPicPr>
-        <p:blipFill>
-          <a:blip r:embed="rId3"/>
-          <a:stretch>
-            <a:fillRect/>
-          </a:stretch>
-        </p:blipFill>
-        <p:spPr>
-          <a:xfrm>
-            <a:off x="548640" y="4846320"/>
-            <a:ext cx="11109960" cy="1280160"/>
-          </a:xfrm>
-          <a:prstGeom prst="rect">
-            <a:avLst/>
-          </a:prstGeom>
-        </p:spPr>
-      </p:pic>
     </p:spTree>
   </p:cSld>
   <p:clrMapOvr>
@@ -11865,7 +11070,23 @@
 
 <file path=ppt/slides/slide9.xml><?xml version="1.0" encoding="utf-8"?>
 <p:sld xmlns:a="http://schemas.openxmlformats.org/drawingml/2006/main" xmlns:r="http://schemas.openxmlformats.org/officeDocument/2006/relationships" xmlns:p="http://schemas.openxmlformats.org/presentationml/2006/main">
+  <p:bg>
+    <p:bgPr>
+      <a:solidFill>
+        <a:srgbClr val="FAF6EE"/>
+      </a:solidFill>
+      <a:effectLst/>
+    </p:bgPr>
+  </p:bg>
   <p:cSld name="Slide 9">
+    <p:bg>
+      <p:bgPr>
+        <a:solidFill>
+          <a:srgbClr val="FAF6EE"/>
+        </a:solidFill>
+        <a:effectLst/>
+      </p:bgPr>
+    </p:bg>
     <p:spTree>
       <p:nvGrpSpPr>
         <p:cNvPr id="1" name=""/>
@@ -12009,7 +11230,40 @@
         <p:txBody>
           <a:bodyPr wrap="square" lIns="127000" tIns="127000" rIns="127000" bIns="127000" rtlCol="0" anchor="ctr"/>
           <a:lstStyle/>
-          <a:p/>
+          <a:p>
+            <a:pPr marL="0" indent="0" algn="ctr">
+              <a:buNone/>
+            </a:pPr>
+            <a:r>
+              <a:rPr lang="en-US" sz="1400" dirty="0">
+                <a:solidFill>
+                  <a:srgbClr val="1D4ED8"/>
+                </a:solidFill>
+                <a:latin typeface="Courier New" pitchFamily="34" charset="0"/>
+                <a:ea typeface="Courier New" pitchFamily="34" charset="-122"/>
+                <a:cs typeface="Courier New" pitchFamily="34" charset="-120"/>
+              </a:rPr>
+              <a:t>SCREENSHOT</a:t>
+            </a:r>
+            <a:endParaRPr lang="en-US" sz="1400" dirty="0"/>
+          </a:p>
+          <a:p>
+            <a:pPr marL="0" indent="0" algn="ctr">
+              <a:buNone/>
+            </a:pPr>
+            <a:r>
+              <a:rPr lang="en-US" sz="1400" dirty="0">
+                <a:solidFill>
+                  <a:srgbClr val="1D4ED8"/>
+                </a:solidFill>
+                <a:latin typeface="Courier New" pitchFamily="34" charset="0"/>
+                <a:ea typeface="Courier New" pitchFamily="34" charset="-122"/>
+                <a:cs typeface="Courier New" pitchFamily="34" charset="-120"/>
+              </a:rPr>
+              <a:t>Live dashboard: budget gauge, reasoning terminal, metric charts</a:t>
+            </a:r>
+            <a:endParaRPr lang="en-US" sz="1400" dirty="0"/>
+          </a:p>
         </p:txBody>
       </p:sp>
       <p:sp>
@@ -12063,7 +11317,40 @@
         <p:txBody>
           <a:bodyPr wrap="square" lIns="127000" tIns="127000" rIns="127000" bIns="127000" rtlCol="0" anchor="ctr"/>
           <a:lstStyle/>
-          <a:p/>
+          <a:p>
+            <a:pPr marL="0" indent="0" algn="ctr">
+              <a:buNone/>
+            </a:pPr>
+            <a:r>
+              <a:rPr lang="en-US" sz="1400" dirty="0">
+                <a:solidFill>
+                  <a:srgbClr val="1D4ED8"/>
+                </a:solidFill>
+                <a:latin typeface="Courier New" pitchFamily="34" charset="0"/>
+                <a:ea typeface="Courier New" pitchFamily="34" charset="-122"/>
+                <a:cs typeface="Courier New" pitchFamily="34" charset="-120"/>
+              </a:rPr>
+              <a:t>SCREENSHOT</a:t>
+            </a:r>
+            <a:endParaRPr lang="en-US" sz="1400" dirty="0"/>
+          </a:p>
+          <a:p>
+            <a:pPr marL="0" indent="0" algn="ctr">
+              <a:buNone/>
+            </a:pPr>
+            <a:r>
+              <a:rPr lang="en-US" sz="1400" dirty="0">
+                <a:solidFill>
+                  <a:srgbClr val="1D4ED8"/>
+                </a:solidFill>
+                <a:latin typeface="Courier New" pitchFamily="34" charset="0"/>
+                <a:ea typeface="Courier New" pitchFamily="34" charset="-122"/>
+                <a:cs typeface="Courier New" pitchFamily="34" charset="-120"/>
+              </a:rPr>
+              <a:t>Hyperparameter table with champion run highlighted</a:t>
+            </a:r>
+            <a:endParaRPr lang="en-US" sz="1400" dirty="0"/>
+          </a:p>
         </p:txBody>
       </p:sp>
       <p:sp>
@@ -12159,15 +11446,8 @@
           <a:bodyPr wrap="square" lIns="0" tIns="0" rIns="0" bIns="0" rtlCol="0" anchor="t"/>
           <a:lstStyle/>
           <a:p>
-            <a:pPr>
-              <a:defRPr sz="1050" i="1">
-                <a:solidFill>
-                  <a:srgbClr val="0F766E"/>
-                </a:solidFill>
-              </a:defRPr>
-            </a:pPr>
-            <a:r>
-              <a:t>"Generalization gap prioritized: pruned tree depth to 5 and scaled L2 regularization to 11.72 with balanced class weights. Overfitting index dropped by 38.9% (11.27% -&gt; 6.88%), securing Champion Model #12 with 0.8506 Val ROC-AUC and 0.8443 Holdout ROC-AUC."</a:t>
+            <a:r>
+              <a:t>"Overfit gap prioritized: pruned depth (6 to 5) and scaled L2 penalty to 14.0 (+366%) with Balanced class weighting. Overfitting index dropped 38.9% (11.27% to 6.88%) while widening class separation margin to 0.3683 (+18.0%). Champion Model #12 achieves 0.8506 OOF ROC-AUC and 0.8443 Sealed Holdout ROC-AUC."</a:t>
             </a:r>
           </a:p>
         </p:txBody>
@@ -12226,39 +11506,26 @@
           <a:p>
             <a:pPr marL="0" indent="0" algn="ctr">
               <a:buNone/>
-              <a:defRPr b="1" sz="1000">
-                <a:solidFill>
-                  <a:srgbClr val="0B1F3A"/>
-                </a:solidFill>
-              </a:defRPr>
-            </a:pPr>
-            <a:r>
-              <a:t>SAMPLE PREDICTIONS (SEALED HOLDOUT)</a:t>
+              <a:defRPr b="1"/>
+            </a:pPr>
+            <a:r>
+              <a:t>SAMPLE PREDICTIONS (SEALED HOLDOUT - 1,409 ROWS)</a:t>
             </a:r>
             <a:endParaRPr lang="en-US" sz="1400" dirty="0"/>
           </a:p>
           <a:p>
-            <a:pPr>
-              <a:defRPr sz="950" b="1">
-                <a:solidFill>
-                  <a:srgbClr val="DC2626"/>
-                </a:solidFill>
-              </a:defRPr>
-            </a:pPr>
-            <a:r>
-              <a:t>• CUST_00001: 89.3% churn risk [HIGH HAZARD]</a:t>
-            </a:r>
-          </a:p>
-          <a:p>
-            <a:pPr>
-              <a:defRPr sz="950" b="1">
-                <a:solidFill>
-                  <a:srgbClr val="0F766E"/>
-                </a:solidFill>
-              </a:defRPr>
-            </a:pPr>
-            <a:r>
-              <a:t>• CUST_00004: 1.8% churn risk [LOYAL / STABLE]</a:t>
+            <a:r>
+              <a:t>• CUST_00001: 89.3% churn risk [HIGH HAZARD - Fiber, M2M]</a:t>
+            </a:r>
+          </a:p>
+          <a:p>
+            <a:r>
+              <a:t>• CUST_00004: 1.8% churn risk [LOYAL / STABLE - 2-Year]</a:t>
+            </a:r>
+          </a:p>
+          <a:p>
+            <a:r>
+              <a:t>• Decision Cutoff J* = 0.49: 78.9% recall (295/374 caught)</a:t>
             </a:r>
           </a:p>
         </p:txBody>
@@ -12311,54 +11578,6 @@
           </a:p>
         </p:txBody>
       </p:sp>
-      <p:pic>
-        <p:nvPicPr>
-          <p:cNvPr id="26" name="Picture 25" descr="dashboard_preview.png"/>
-          <p:cNvPicPr>
-            <a:picLocks noChangeAspect="1"/>
-          </p:cNvPicPr>
-          <p:nvPr/>
-        </p:nvPicPr>
-        <p:blipFill>
-          <a:blip r:embed="rId3"/>
-          <a:stretch>
-            <a:fillRect/>
-          </a:stretch>
-        </p:blipFill>
-        <p:spPr>
-          <a:xfrm>
-            <a:off x="548640" y="1280160"/>
-            <a:ext cx="5486400" cy="3017520"/>
-          </a:xfrm>
-          <a:prstGeom prst="rect">
-            <a:avLst/>
-          </a:prstGeom>
-        </p:spPr>
-      </p:pic>
-      <p:pic>
-        <p:nvPicPr>
-          <p:cNvPr id="27" name="Picture 26" descr="hyperparameters_preview.png"/>
-          <p:cNvPicPr>
-            <a:picLocks noChangeAspect="1"/>
-          </p:cNvPicPr>
-          <p:nvPr/>
-        </p:nvPicPr>
-        <p:blipFill>
-          <a:blip r:embed="rId4"/>
-          <a:stretch>
-            <a:fillRect/>
-          </a:stretch>
-        </p:blipFill>
-        <p:spPr>
-          <a:xfrm>
-            <a:off x="6172200" y="1280160"/>
-            <a:ext cx="5486400" cy="3017520"/>
-          </a:xfrm>
-          <a:prstGeom prst="rect">
-            <a:avLst/>
-          </a:prstGeom>
-        </p:spPr>
-      </p:pic>
     </p:spTree>
   </p:cSld>
   <p:clrMapOvr>

</xml_diff>

<commit_message>
style(ppt): add cream geometric wireframe line network to all slide backgrounds
</commit_message>
<xml_diff>
--- a/ppt/QUANTA_PPT.pptx
+++ b/ppt/QUANTA_PPT.pptx
@@ -1630,6 +1630,30 @@
           <a:chExt cx="0" cy="0"/>
         </a:xfrm>
       </p:grpSpPr>
+      <p:pic>
+        <p:nvPicPr>
+          <p:cNvPr id="26" name="Picture 25" descr="cream_wireframe_bg.png"/>
+          <p:cNvPicPr>
+            <a:picLocks noChangeAspect="1"/>
+          </p:cNvPicPr>
+          <p:nvPr/>
+        </p:nvPicPr>
+        <p:blipFill>
+          <a:blip r:embed="rId3"/>
+          <a:stretch>
+            <a:fillRect/>
+          </a:stretch>
+        </p:blipFill>
+        <p:spPr>
+          <a:xfrm>
+            <a:off x="0" y="0"/>
+            <a:ext cx="12192000" cy="6858000"/>
+          </a:xfrm>
+          <a:prstGeom prst="rect">
+            <a:avLst/>
+          </a:prstGeom>
+        </p:spPr>
+      </p:pic>
       <p:sp>
         <p:nvSpPr>
           <p:cNvPr id="2" name="Text 0"/>
@@ -2225,6 +2249,30 @@
           <a:chExt cx="0" cy="0"/>
         </a:xfrm>
       </p:grpSpPr>
+      <p:pic>
+        <p:nvPicPr>
+          <p:cNvPr id="26" name="Picture 25" descr="cream_wireframe_bg.png"/>
+          <p:cNvPicPr>
+            <a:picLocks noChangeAspect="1"/>
+          </p:cNvPicPr>
+          <p:nvPr/>
+        </p:nvPicPr>
+        <p:blipFill>
+          <a:blip r:embed="rId3"/>
+          <a:stretch>
+            <a:fillRect/>
+          </a:stretch>
+        </p:blipFill>
+        <p:spPr>
+          <a:xfrm>
+            <a:off x="0" y="0"/>
+            <a:ext cx="12192000" cy="6858000"/>
+          </a:xfrm>
+          <a:prstGeom prst="rect">
+            <a:avLst/>
+          </a:prstGeom>
+        </p:spPr>
+      </p:pic>
       <p:sp>
         <p:nvSpPr>
           <p:cNvPr id="2" name="Text 0"/>
@@ -2884,6 +2932,30 @@
           <a:chExt cx="0" cy="0"/>
         </a:xfrm>
       </p:grpSpPr>
+      <p:pic>
+        <p:nvPicPr>
+          <p:cNvPr id="26" name="Picture 25" descr="cream_wireframe_bg.png"/>
+          <p:cNvPicPr>
+            <a:picLocks noChangeAspect="1"/>
+          </p:cNvPicPr>
+          <p:nvPr/>
+        </p:nvPicPr>
+        <p:blipFill>
+          <a:blip r:embed="rId3"/>
+          <a:stretch>
+            <a:fillRect/>
+          </a:stretch>
+        </p:blipFill>
+        <p:spPr>
+          <a:xfrm>
+            <a:off x="0" y="0"/>
+            <a:ext cx="12192000" cy="6858000"/>
+          </a:xfrm>
+          <a:prstGeom prst="rect">
+            <a:avLst/>
+          </a:prstGeom>
+        </p:spPr>
+      </p:pic>
       <p:sp>
         <p:nvSpPr>
           <p:cNvPr id="2" name="Text 0"/>
@@ -3678,6 +3750,30 @@
           <a:chExt cx="0" cy="0"/>
         </a:xfrm>
       </p:grpSpPr>
+      <p:pic>
+        <p:nvPicPr>
+          <p:cNvPr id="26" name="Picture 25" descr="cream_wireframe_bg.png"/>
+          <p:cNvPicPr>
+            <a:picLocks noChangeAspect="1"/>
+          </p:cNvPicPr>
+          <p:nvPr/>
+        </p:nvPicPr>
+        <p:blipFill>
+          <a:blip r:embed="rId3"/>
+          <a:stretch>
+            <a:fillRect/>
+          </a:stretch>
+        </p:blipFill>
+        <p:spPr>
+          <a:xfrm>
+            <a:off x="0" y="0"/>
+            <a:ext cx="12192000" cy="6858000"/>
+          </a:xfrm>
+          <a:prstGeom prst="rect">
+            <a:avLst/>
+          </a:prstGeom>
+        </p:spPr>
+      </p:pic>
       <p:sp>
         <p:nvSpPr>
           <p:cNvPr id="2" name="Text 0"/>
@@ -4650,6 +4746,30 @@
           <a:chExt cx="0" cy="0"/>
         </a:xfrm>
       </p:grpSpPr>
+      <p:pic>
+        <p:nvPicPr>
+          <p:cNvPr id="30" name="Picture 29" descr="cream_wireframe_bg.png"/>
+          <p:cNvPicPr>
+            <a:picLocks noChangeAspect="1"/>
+          </p:cNvPicPr>
+          <p:nvPr/>
+        </p:nvPicPr>
+        <p:blipFill>
+          <a:blip r:embed="rId3"/>
+          <a:stretch>
+            <a:fillRect/>
+          </a:stretch>
+        </p:blipFill>
+        <p:spPr>
+          <a:xfrm>
+            <a:off x="0" y="0"/>
+            <a:ext cx="12192000" cy="6858000"/>
+          </a:xfrm>
+          <a:prstGeom prst="rect">
+            <a:avLst/>
+          </a:prstGeom>
+        </p:spPr>
+      </p:pic>
       <p:sp>
         <p:nvSpPr>
           <p:cNvPr id="2" name="Text 0"/>
@@ -5881,6 +6001,30 @@
           <a:chExt cx="0" cy="0"/>
         </a:xfrm>
       </p:grpSpPr>
+      <p:pic>
+        <p:nvPicPr>
+          <p:cNvPr id="28" name="Picture 27" descr="cream_wireframe_bg.png"/>
+          <p:cNvPicPr>
+            <a:picLocks noChangeAspect="1"/>
+          </p:cNvPicPr>
+          <p:nvPr/>
+        </p:nvPicPr>
+        <p:blipFill>
+          <a:blip r:embed="rId3"/>
+          <a:stretch>
+            <a:fillRect/>
+          </a:stretch>
+        </p:blipFill>
+        <p:spPr>
+          <a:xfrm>
+            <a:off x="0" y="0"/>
+            <a:ext cx="12192000" cy="6858000"/>
+          </a:xfrm>
+          <a:prstGeom prst="rect">
+            <a:avLst/>
+          </a:prstGeom>
+        </p:spPr>
+      </p:pic>
       <p:sp>
         <p:nvSpPr>
           <p:cNvPr id="2" name="Text 0"/>
@@ -6959,6 +7103,30 @@
           <a:chExt cx="0" cy="0"/>
         </a:xfrm>
       </p:grpSpPr>
+      <p:pic>
+        <p:nvPicPr>
+          <p:cNvPr id="26" name="Picture 25" descr="cream_wireframe_bg.png"/>
+          <p:cNvPicPr>
+            <a:picLocks noChangeAspect="1"/>
+          </p:cNvPicPr>
+          <p:nvPr/>
+        </p:nvPicPr>
+        <p:blipFill>
+          <a:blip r:embed="rId3"/>
+          <a:stretch>
+            <a:fillRect/>
+          </a:stretch>
+        </p:blipFill>
+        <p:spPr>
+          <a:xfrm>
+            <a:off x="0" y="0"/>
+            <a:ext cx="12192000" cy="6858000"/>
+          </a:xfrm>
+          <a:prstGeom prst="rect">
+            <a:avLst/>
+          </a:prstGeom>
+        </p:spPr>
+      </p:pic>
       <p:sp>
         <p:nvSpPr>
           <p:cNvPr id="2" name="Text 0"/>
@@ -7804,6 +7972,30 @@
           <a:chExt cx="0" cy="0"/>
         </a:xfrm>
       </p:grpSpPr>
+      <p:pic>
+        <p:nvPicPr>
+          <p:cNvPr id="35" name="Picture 34" descr="cream_wireframe_bg.png"/>
+          <p:cNvPicPr>
+            <a:picLocks noChangeAspect="1"/>
+          </p:cNvPicPr>
+          <p:nvPr/>
+        </p:nvPicPr>
+        <p:blipFill>
+          <a:blip r:embed="rId3"/>
+          <a:stretch>
+            <a:fillRect/>
+          </a:stretch>
+        </p:blipFill>
+        <p:spPr>
+          <a:xfrm>
+            <a:off x="0" y="0"/>
+            <a:ext cx="12192000" cy="6858000"/>
+          </a:xfrm>
+          <a:prstGeom prst="rect">
+            <a:avLst/>
+          </a:prstGeom>
+        </p:spPr>
+      </p:pic>
       <p:sp>
         <p:nvSpPr>
           <p:cNvPr id="2" name="Text 0"/>
@@ -8997,6 +9189,30 @@
           <a:chExt cx="0" cy="0"/>
         </a:xfrm>
       </p:grpSpPr>
+      <p:pic>
+        <p:nvPicPr>
+          <p:cNvPr id="26" name="Picture 25" descr="cream_wireframe_bg.png"/>
+          <p:cNvPicPr>
+            <a:picLocks noChangeAspect="1"/>
+          </p:cNvPicPr>
+          <p:nvPr/>
+        </p:nvPicPr>
+        <p:blipFill>
+          <a:blip r:embed="rId3"/>
+          <a:stretch>
+            <a:fillRect/>
+          </a:stretch>
+        </p:blipFill>
+        <p:spPr>
+          <a:xfrm>
+            <a:off x="0" y="0"/>
+            <a:ext cx="12192000" cy="6858000"/>
+          </a:xfrm>
+          <a:prstGeom prst="rect">
+            <a:avLst/>
+          </a:prstGeom>
+        </p:spPr>
+      </p:pic>
       <p:sp>
         <p:nvSpPr>
           <p:cNvPr id="2" name="Text 0"/>
@@ -11101,6 +11317,30 @@
           <a:chExt cx="0" cy="0"/>
         </a:xfrm>
       </p:grpSpPr>
+      <p:pic>
+        <p:nvPicPr>
+          <p:cNvPr id="26" name="Picture 25" descr="cream_wireframe_bg.png"/>
+          <p:cNvPicPr>
+            <a:picLocks noChangeAspect="1"/>
+          </p:cNvPicPr>
+          <p:nvPr/>
+        </p:nvPicPr>
+        <p:blipFill>
+          <a:blip r:embed="rId3"/>
+          <a:stretch>
+            <a:fillRect/>
+          </a:stretch>
+        </p:blipFill>
+        <p:spPr>
+          <a:xfrm>
+            <a:off x="0" y="0"/>
+            <a:ext cx="12192000" cy="6858000"/>
+          </a:xfrm>
+          <a:prstGeom prst="rect">
+            <a:avLst/>
+          </a:prstGeom>
+        </p:spPr>
+      </p:pic>
       <p:sp>
         <p:nvSpPr>
           <p:cNvPr id="2" name="Text 0"/>

</xml_diff>